<commit_message>
Plasma stability with PPT generation and summary page for molecules
</commit_message>
<xml_diff>
--- a/plotly_integration/dash_apps/Analytical/plasma_stability_v2/template/Plasma Stability Report.pptx
+++ b/plotly_integration/dash_apps/Analytical/plasma_stability_v2/template/Plasma Stability Report.pptx
@@ -3780,89 +3780,88 @@
           <p:cNvGraphicFramePr>
             <a:graphicFrameLocks noGrp="1"/>
           </p:cNvGraphicFramePr>
-          <p:nvPr/>
+          <p:nvPr>
+            <p:extLst>
+              <p:ext uri="{D42A27DB-BD31-4B8C-83A1-F6EECF244321}">
+                <p14:modId xmlns:p14="http://schemas.microsoft.com/office/powerpoint/2010/main" val="460834027"/>
+              </p:ext>
+            </p:extLst>
+          </p:nvPr>
         </p:nvGraphicFramePr>
         <p:xfrm>
-          <a:off x="433136" y="264695"/>
-          <a:ext cx="11333750" cy="5910919"/>
+          <a:off x="392413" y="356716"/>
+          <a:ext cx="11407174" cy="6144568"/>
         </p:xfrm>
         <a:graphic>
           <a:graphicData uri="http://schemas.openxmlformats.org/drawingml/2006/table">
             <a:tbl>
               <a:tblPr/>
               <a:tblGrid>
-                <a:gridCol w="1133375">
+                <a:gridCol w="862264">
                   <a:extLst>
                     <a:ext uri="{9D8B030D-6E8A-4147-A177-3AD203B41FA5}">
                       <a16:colId xmlns:a16="http://schemas.microsoft.com/office/drawing/2014/main" val="948571303"/>
                     </a:ext>
                   </a:extLst>
                 </a:gridCol>
-                <a:gridCol w="1133375">
+                <a:gridCol w="1227667">
                   <a:extLst>
                     <a:ext uri="{9D8B030D-6E8A-4147-A177-3AD203B41FA5}">
                       <a16:colId xmlns:a16="http://schemas.microsoft.com/office/drawing/2014/main" val="1394502120"/>
                     </a:ext>
                   </a:extLst>
                 </a:gridCol>
-                <a:gridCol w="512546">
+                <a:gridCol w="753533">
                   <a:extLst>
                     <a:ext uri="{9D8B030D-6E8A-4147-A177-3AD203B41FA5}">
                       <a16:colId xmlns:a16="http://schemas.microsoft.com/office/drawing/2014/main" val="3611935111"/>
                     </a:ext>
                   </a:extLst>
                 </a:gridCol>
-                <a:gridCol w="1754204">
+                <a:gridCol w="1427285">
                   <a:extLst>
                     <a:ext uri="{9D8B030D-6E8A-4147-A177-3AD203B41FA5}">
                       <a16:colId xmlns:a16="http://schemas.microsoft.com/office/drawing/2014/main" val="3649209437"/>
                     </a:ext>
                   </a:extLst>
                 </a:gridCol>
-                <a:gridCol w="1133375">
+                <a:gridCol w="1427285">
                   <a:extLst>
                     <a:ext uri="{9D8B030D-6E8A-4147-A177-3AD203B41FA5}">
                       <a16:colId xmlns:a16="http://schemas.microsoft.com/office/drawing/2014/main" val="1494910683"/>
                     </a:ext>
                   </a:extLst>
                 </a:gridCol>
-                <a:gridCol w="1133375">
+                <a:gridCol w="1427285">
                   <a:extLst>
                     <a:ext uri="{9D8B030D-6E8A-4147-A177-3AD203B41FA5}">
                       <a16:colId xmlns:a16="http://schemas.microsoft.com/office/drawing/2014/main" val="1131162997"/>
                     </a:ext>
                   </a:extLst>
                 </a:gridCol>
-                <a:gridCol w="1133375">
+                <a:gridCol w="1427285">
                   <a:extLst>
                     <a:ext uri="{9D8B030D-6E8A-4147-A177-3AD203B41FA5}">
                       <a16:colId xmlns:a16="http://schemas.microsoft.com/office/drawing/2014/main" val="1405522017"/>
                     </a:ext>
                   </a:extLst>
                 </a:gridCol>
-                <a:gridCol w="1133375">
+                <a:gridCol w="1427285">
                   <a:extLst>
                     <a:ext uri="{9D8B030D-6E8A-4147-A177-3AD203B41FA5}">
                       <a16:colId xmlns:a16="http://schemas.microsoft.com/office/drawing/2014/main" val="1402052073"/>
                     </a:ext>
                   </a:extLst>
                 </a:gridCol>
-                <a:gridCol w="1133375">
+                <a:gridCol w="1427285">
                   <a:extLst>
                     <a:ext uri="{9D8B030D-6E8A-4147-A177-3AD203B41FA5}">
                       <a16:colId xmlns:a16="http://schemas.microsoft.com/office/drawing/2014/main" val="3081383312"/>
                     </a:ext>
                   </a:extLst>
                 </a:gridCol>
-                <a:gridCol w="1133375">
-                  <a:extLst>
-                    <a:ext uri="{9D8B030D-6E8A-4147-A177-3AD203B41FA5}">
-                      <a16:colId xmlns:a16="http://schemas.microsoft.com/office/drawing/2014/main" val="3174663583"/>
-                    </a:ext>
-                  </a:extLst>
-                </a:gridCol>
               </a:tblGrid>
-              <a:tr h="1383631">
+              <a:tr h="1332788">
                 <a:tc gridSpan="3">
                   <a:txBody>
                     <a:bodyPr/>
@@ -3952,7 +3951,7 @@
                         <a:buNone/>
                       </a:pPr>
                       <a:r>
-                        <a:rPr lang="en-US" sz="1800" b="0" i="0" u="none" strike="noStrike">
+                        <a:rPr lang="en-US" sz="1800" b="0" i="0" u="none" strike="noStrike" dirty="0">
                           <a:solidFill>
                             <a:srgbClr val="000000"/>
                           </a:solidFill>
@@ -4001,7 +4000,131 @@
                       <a:tailEnd type="none" w="med" len="med"/>
                     </a:lnB>
                     <a:solidFill>
-                      <a:srgbClr val="D9F2D0"/>
+                      <a:schemeClr val="bg1"/>
+                    </a:solidFill>
+                  </a:tcPr>
+                </a:tc>
+                <a:tc>
+                  <a:txBody>
+                    <a:bodyPr/>
+                    <a:lstStyle/>
+                    <a:p>
+                      <a:pPr algn="ctr" fontAlgn="ctr">
+                        <a:buNone/>
+                      </a:pPr>
+                      <a:r>
+                        <a:rPr lang="en-US" sz="1800" b="0" i="0" u="none" strike="noStrike" dirty="0">
+                          <a:solidFill>
+                            <a:srgbClr val="000000"/>
+                          </a:solidFill>
+                          <a:effectLst/>
+                          <a:latin typeface="Arial" panose="020B0604020202020204" pitchFamily="34" charset="0"/>
+                        </a:rPr>
+                        <a:t> </a:t>
+                      </a:r>
+                    </a:p>
+                  </a:txBody>
+                  <a:tcPr marL="6350" marR="6350" marT="6350" marB="0" anchor="ctr">
+                    <a:lnL w="12700" cap="flat" cmpd="sng" algn="ctr">
+                      <a:solidFill>
+                        <a:srgbClr val="000000"/>
+                      </a:solidFill>
+                      <a:prstDash val="solid"/>
+                      <a:round/>
+                      <a:headEnd type="none" w="med" len="med"/>
+                      <a:tailEnd type="none" w="med" len="med"/>
+                    </a:lnL>
+                    <a:lnR w="12700" cap="flat" cmpd="sng" algn="ctr">
+                      <a:solidFill>
+                        <a:srgbClr val="000000"/>
+                      </a:solidFill>
+                      <a:prstDash val="solid"/>
+                      <a:round/>
+                      <a:headEnd type="none" w="med" len="med"/>
+                      <a:tailEnd type="none" w="med" len="med"/>
+                    </a:lnR>
+                    <a:lnT w="12700" cap="flat" cmpd="sng" algn="ctr">
+                      <a:solidFill>
+                        <a:srgbClr val="000000"/>
+                      </a:solidFill>
+                      <a:prstDash val="solid"/>
+                      <a:round/>
+                      <a:headEnd type="none" w="med" len="med"/>
+                      <a:tailEnd type="none" w="med" len="med"/>
+                    </a:lnT>
+                    <a:lnB w="12700" cap="flat" cmpd="sng" algn="ctr">
+                      <a:solidFill>
+                        <a:srgbClr val="000000"/>
+                      </a:solidFill>
+                      <a:prstDash val="solid"/>
+                      <a:round/>
+                      <a:headEnd type="none" w="med" len="med"/>
+                      <a:tailEnd type="none" w="med" len="med"/>
+                    </a:lnB>
+                    <a:solidFill>
+                      <a:schemeClr val="bg1"/>
+                    </a:solidFill>
+                  </a:tcPr>
+                </a:tc>
+                <a:tc>
+                  <a:txBody>
+                    <a:bodyPr/>
+                    <a:lstStyle/>
+                    <a:p>
+                      <a:pPr algn="ctr" fontAlgn="ctr">
+                        <a:buNone/>
+                      </a:pPr>
+                      <a:r>
+                        <a:rPr lang="en-US" sz="1800" b="0" i="0" u="none" strike="noStrike" dirty="0">
+                          <a:solidFill>
+                            <a:srgbClr val="000000"/>
+                          </a:solidFill>
+                          <a:effectLst/>
+                          <a:latin typeface="Arial" panose="020B0604020202020204" pitchFamily="34" charset="0"/>
+                        </a:rPr>
+                        <a:t> </a:t>
+                      </a:r>
+                    </a:p>
+                  </a:txBody>
+                  <a:tcPr marL="6350" marR="6350" marT="6350" marB="0" anchor="ctr">
+                    <a:lnL w="12700" cap="flat" cmpd="sng" algn="ctr">
+                      <a:solidFill>
+                        <a:srgbClr val="000000"/>
+                      </a:solidFill>
+                      <a:prstDash val="solid"/>
+                      <a:round/>
+                      <a:headEnd type="none" w="med" len="med"/>
+                      <a:tailEnd type="none" w="med" len="med"/>
+                    </a:lnL>
+                    <a:lnR w="12700" cap="flat" cmpd="sng" algn="ctr">
+                      <a:solidFill>
+                        <a:srgbClr val="000000"/>
+                      </a:solidFill>
+                      <a:prstDash val="solid"/>
+                      <a:round/>
+                      <a:headEnd type="none" w="med" len="med"/>
+                      <a:tailEnd type="none" w="med" len="med"/>
+                    </a:lnR>
+                    <a:lnT w="12700" cap="flat" cmpd="sng" algn="ctr">
+                      <a:solidFill>
+                        <a:srgbClr val="000000"/>
+                      </a:solidFill>
+                      <a:prstDash val="solid"/>
+                      <a:round/>
+                      <a:headEnd type="none" w="med" len="med"/>
+                      <a:tailEnd type="none" w="med" len="med"/>
+                    </a:lnT>
+                    <a:lnB w="12700" cap="flat" cmpd="sng" algn="ctr">
+                      <a:solidFill>
+                        <a:srgbClr val="000000"/>
+                      </a:solidFill>
+                      <a:prstDash val="solid"/>
+                      <a:round/>
+                      <a:headEnd type="none" w="med" len="med"/>
+                      <a:tailEnd type="none" w="med" len="med"/>
+                    </a:lnB>
+                    <a:solidFill>
+                      <a:schemeClr val="bg1"/>
                     </a:solidFill>
                   </a:tcPr>
                 </a:tc>
@@ -4063,7 +4186,7 @@
                       <a:tailEnd type="none" w="med" len="med"/>
                     </a:lnB>
                     <a:solidFill>
-                      <a:srgbClr val="D9F2D0"/>
+                      <a:schemeClr val="bg1"/>
                     </a:solidFill>
                   </a:tcPr>
                 </a:tc>
@@ -4125,7 +4248,7 @@
                       <a:tailEnd type="none" w="med" len="med"/>
                     </a:lnB>
                     <a:solidFill>
-                      <a:srgbClr val="D9F2D0"/>
+                      <a:schemeClr val="bg1"/>
                     </a:solidFill>
                   </a:tcPr>
                 </a:tc>
@@ -4186,187 +4309,9 @@
                       <a:headEnd type="none" w="med" len="med"/>
                       <a:tailEnd type="none" w="med" len="med"/>
                     </a:lnB>
-                    <a:noFill/>
-                  </a:tcPr>
-                </a:tc>
-                <a:tc>
-                  <a:txBody>
-                    <a:bodyPr/>
-                    <a:lstStyle/>
-                    <a:p>
-                      <a:pPr algn="ctr" fontAlgn="ctr">
-                        <a:buNone/>
-                      </a:pPr>
-                      <a:r>
-                        <a:rPr lang="en-US" sz="1800" b="0" i="0" u="none" strike="noStrike">
-                          <a:solidFill>
-                            <a:srgbClr val="000000"/>
-                          </a:solidFill>
-                          <a:effectLst/>
-                          <a:latin typeface="Arial" panose="020B0604020202020204" pitchFamily="34" charset="0"/>
-                        </a:rPr>
-                        <a:t> </a:t>
-                      </a:r>
-                    </a:p>
-                  </a:txBody>
-                  <a:tcPr marL="6350" marR="6350" marT="6350" marB="0" anchor="ctr">
-                    <a:lnL w="12700" cap="flat" cmpd="sng" algn="ctr">
-                      <a:solidFill>
-                        <a:srgbClr val="000000"/>
-                      </a:solidFill>
-                      <a:prstDash val="solid"/>
-                      <a:round/>
-                      <a:headEnd type="none" w="med" len="med"/>
-                      <a:tailEnd type="none" w="med" len="med"/>
-                    </a:lnL>
-                    <a:lnR w="12700" cap="flat" cmpd="sng" algn="ctr">
-                      <a:solidFill>
-                        <a:srgbClr val="000000"/>
-                      </a:solidFill>
-                      <a:prstDash val="solid"/>
-                      <a:round/>
-                      <a:headEnd type="none" w="med" len="med"/>
-                      <a:tailEnd type="none" w="med" len="med"/>
-                    </a:lnR>
-                    <a:lnT w="12700" cap="flat" cmpd="sng" algn="ctr">
-                      <a:solidFill>
-                        <a:srgbClr val="000000"/>
-                      </a:solidFill>
-                      <a:prstDash val="solid"/>
-                      <a:round/>
-                      <a:headEnd type="none" w="med" len="med"/>
-                      <a:tailEnd type="none" w="med" len="med"/>
-                    </a:lnT>
-                    <a:lnB w="12700" cap="flat" cmpd="sng" algn="ctr">
-                      <a:solidFill>
-                        <a:srgbClr val="000000"/>
-                      </a:solidFill>
-                      <a:prstDash val="solid"/>
-                      <a:round/>
-                      <a:headEnd type="none" w="med" len="med"/>
-                      <a:tailEnd type="none" w="med" len="med"/>
-                    </a:lnB>
-                    <a:noFill/>
-                  </a:tcPr>
-                </a:tc>
-                <a:tc>
-                  <a:txBody>
-                    <a:bodyPr/>
-                    <a:lstStyle/>
-                    <a:p>
-                      <a:pPr algn="ctr" fontAlgn="ctr">
-                        <a:buNone/>
-                      </a:pPr>
-                      <a:r>
-                        <a:rPr lang="en-US" sz="1800" b="0" i="0" u="none" strike="noStrike">
-                          <a:solidFill>
-                            <a:srgbClr val="000000"/>
-                          </a:solidFill>
-                          <a:effectLst/>
-                          <a:latin typeface="Arial" panose="020B0604020202020204" pitchFamily="34" charset="0"/>
-                        </a:rPr>
-                        <a:t> </a:t>
-                      </a:r>
-                    </a:p>
-                  </a:txBody>
-                  <a:tcPr marL="6350" marR="6350" marT="6350" marB="0" anchor="ctr">
-                    <a:lnL w="12700" cap="flat" cmpd="sng" algn="ctr">
-                      <a:solidFill>
-                        <a:srgbClr val="000000"/>
-                      </a:solidFill>
-                      <a:prstDash val="solid"/>
-                      <a:round/>
-                      <a:headEnd type="none" w="med" len="med"/>
-                      <a:tailEnd type="none" w="med" len="med"/>
-                    </a:lnL>
-                    <a:lnR w="12700" cap="flat" cmpd="sng" algn="ctr">
-                      <a:solidFill>
-                        <a:srgbClr val="000000"/>
-                      </a:solidFill>
-                      <a:prstDash val="solid"/>
-                      <a:round/>
-                      <a:headEnd type="none" w="med" len="med"/>
-                      <a:tailEnd type="none" w="med" len="med"/>
-                    </a:lnR>
-                    <a:lnT w="12700" cap="flat" cmpd="sng" algn="ctr">
-                      <a:solidFill>
-                        <a:srgbClr val="000000"/>
-                      </a:solidFill>
-                      <a:prstDash val="solid"/>
-                      <a:round/>
-                      <a:headEnd type="none" w="med" len="med"/>
-                      <a:tailEnd type="none" w="med" len="med"/>
-                    </a:lnT>
-                    <a:lnB w="12700" cap="flat" cmpd="sng" algn="ctr">
-                      <a:solidFill>
-                        <a:srgbClr val="000000"/>
-                      </a:solidFill>
-                      <a:prstDash val="solid"/>
-                      <a:round/>
-                      <a:headEnd type="none" w="med" len="med"/>
-                      <a:tailEnd type="none" w="med" len="med"/>
-                    </a:lnB>
-                    <a:noFill/>
-                  </a:tcPr>
-                </a:tc>
-                <a:tc>
-                  <a:txBody>
-                    <a:bodyPr/>
-                    <a:lstStyle/>
-                    <a:p>
-                      <a:pPr algn="ctr" fontAlgn="ctr">
-                        <a:buNone/>
-                      </a:pPr>
-                      <a:r>
-                        <a:rPr lang="en-US" sz="1800" b="0" i="0" u="none" strike="noStrike">
-                          <a:solidFill>
-                            <a:srgbClr val="000000"/>
-                          </a:solidFill>
-                          <a:effectLst/>
-                          <a:latin typeface="Arial" panose="020B0604020202020204" pitchFamily="34" charset="0"/>
-                        </a:rPr>
-                        <a:t> </a:t>
-                      </a:r>
-                    </a:p>
-                  </a:txBody>
-                  <a:tcPr marL="6350" marR="6350" marT="6350" marB="0" anchor="ctr">
-                    <a:lnL w="12700" cap="flat" cmpd="sng" algn="ctr">
-                      <a:solidFill>
-                        <a:srgbClr val="000000"/>
-                      </a:solidFill>
-                      <a:prstDash val="solid"/>
-                      <a:round/>
-                      <a:headEnd type="none" w="med" len="med"/>
-                      <a:tailEnd type="none" w="med" len="med"/>
-                    </a:lnL>
-                    <a:lnR w="12700" cap="flat" cmpd="sng" algn="ctr">
-                      <a:solidFill>
-                        <a:srgbClr val="000000"/>
-                      </a:solidFill>
-                      <a:prstDash val="solid"/>
-                      <a:round/>
-                      <a:headEnd type="none" w="med" len="med"/>
-                      <a:tailEnd type="none" w="med" len="med"/>
-                    </a:lnR>
-                    <a:lnT w="12700" cap="flat" cmpd="sng" algn="ctr">
-                      <a:solidFill>
-                        <a:srgbClr val="000000"/>
-                      </a:solidFill>
-                      <a:prstDash val="solid"/>
-                      <a:round/>
-                      <a:headEnd type="none" w="med" len="med"/>
-                      <a:tailEnd type="none" w="med" len="med"/>
-                    </a:lnT>
-                    <a:lnB w="12700" cap="flat" cmpd="sng" algn="ctr">
-                      <a:solidFill>
-                        <a:srgbClr val="000000"/>
-                      </a:solidFill>
-                      <a:prstDash val="solid"/>
-                      <a:round/>
-                      <a:headEnd type="none" w="med" len="med"/>
-                      <a:tailEnd type="none" w="med" len="med"/>
-                    </a:lnB>
-                    <a:noFill/>
+                    <a:solidFill>
+                      <a:schemeClr val="bg1"/>
+                    </a:solidFill>
                   </a:tcPr>
                 </a:tc>
                 <a:extLst>
@@ -4375,7 +4320,7 @@
                   </a:ext>
                 </a:extLst>
               </a:tr>
-              <a:tr h="427121">
+              <a:tr h="389585">
                 <a:tc gridSpan="3">
                   <a:txBody>
                     <a:bodyPr/>
@@ -4385,7 +4330,7 @@
                         <a:buNone/>
                       </a:pPr>
                       <a:r>
-                        <a:rPr lang="en-US" sz="1600" b="1" i="0" u="none" strike="noStrike">
+                        <a:rPr lang="en-US" sz="1600" b="1" i="0" u="none" strike="noStrike" dirty="0">
                           <a:solidFill>
                             <a:srgbClr val="000000"/>
                           </a:solidFill>
@@ -4464,16 +4409,13 @@
                       <a:pPr algn="ctr" rtl="0" fontAlgn="b">
                         <a:buNone/>
                       </a:pPr>
-                      <a:r>
-                        <a:rPr lang="en-US" sz="2000" b="1" i="0" u="none" strike="noStrike">
-                          <a:solidFill>
-                            <a:srgbClr val="000000"/>
-                          </a:solidFill>
-                          <a:effectLst/>
-                          <a:latin typeface="Aptos Narrow" panose="020B0004020202020204" pitchFamily="34" charset="0"/>
-                        </a:rPr>
-                        <a:t>212T14*</a:t>
-                      </a:r>
+                      <a:endParaRPr lang="en-US" sz="2000" b="1" i="0" u="none" strike="noStrike" dirty="0">
+                        <a:solidFill>
+                          <a:srgbClr val="000000"/>
+                        </a:solidFill>
+                        <a:effectLst/>
+                        <a:latin typeface="Aptos Narrow" panose="020B0004020202020204" pitchFamily="34" charset="0"/>
+                      </a:endParaRPr>
                     </a:p>
                   </a:txBody>
                   <a:tcPr marL="6350" marR="6350" marT="6350" marB="0" anchor="ctr">
@@ -4514,7 +4456,7 @@
                       <a:tailEnd type="none" w="med" len="med"/>
                     </a:lnB>
                     <a:solidFill>
-                      <a:srgbClr val="D9F2D0"/>
+                      <a:schemeClr val="bg1"/>
                     </a:solidFill>
                   </a:tcPr>
                 </a:tc>
@@ -4526,16 +4468,13 @@
                       <a:pPr algn="ctr" rtl="0" fontAlgn="b">
                         <a:buNone/>
                       </a:pPr>
-                      <a:r>
-                        <a:rPr lang="en-US" sz="2000" b="1" i="0" u="none" strike="noStrike">
-                          <a:solidFill>
-                            <a:srgbClr val="000000"/>
-                          </a:solidFill>
-                          <a:effectLst/>
-                          <a:latin typeface="Aptos Narrow" panose="020B0004020202020204" pitchFamily="34" charset="0"/>
-                        </a:rPr>
-                        <a:t>212X1</a:t>
-                      </a:r>
+                      <a:endParaRPr lang="en-US" sz="2000" b="1" i="0" u="none" strike="noStrike" dirty="0">
+                        <a:solidFill>
+                          <a:srgbClr val="000000"/>
+                        </a:solidFill>
+                        <a:effectLst/>
+                        <a:latin typeface="Aptos Narrow" panose="020B0004020202020204" pitchFamily="34" charset="0"/>
+                      </a:endParaRPr>
                     </a:p>
                   </a:txBody>
                   <a:tcPr marL="6350" marR="6350" marT="6350" marB="0" anchor="ctr">
@@ -4576,7 +4515,7 @@
                       <a:tailEnd type="none" w="med" len="med"/>
                     </a:lnB>
                     <a:solidFill>
-                      <a:srgbClr val="D9F2D0"/>
+                      <a:schemeClr val="bg1"/>
                     </a:solidFill>
                   </a:tcPr>
                 </a:tc>
@@ -4588,16 +4527,13 @@
                       <a:pPr algn="ctr" rtl="0" fontAlgn="b">
                         <a:buNone/>
                       </a:pPr>
-                      <a:r>
-                        <a:rPr lang="en-US" sz="2000" b="1" i="0" u="none" strike="noStrike">
-                          <a:solidFill>
-                            <a:srgbClr val="000000"/>
-                          </a:solidFill>
-                          <a:effectLst/>
-                          <a:latin typeface="Aptos Narrow" panose="020B0004020202020204" pitchFamily="34" charset="0"/>
-                        </a:rPr>
-                        <a:t>212X8</a:t>
-                      </a:r>
+                      <a:endParaRPr lang="en-US" sz="2000" b="1" i="0" u="none" strike="noStrike" dirty="0">
+                        <a:solidFill>
+                          <a:srgbClr val="000000"/>
+                        </a:solidFill>
+                        <a:effectLst/>
+                        <a:latin typeface="Aptos Narrow" panose="020B0004020202020204" pitchFamily="34" charset="0"/>
+                      </a:endParaRPr>
                     </a:p>
                   </a:txBody>
                   <a:tcPr marL="6350" marR="6350" marT="6350" marB="0" anchor="ctr">
@@ -4638,7 +4574,7 @@
                       <a:tailEnd type="none" w="med" len="med"/>
                     </a:lnB>
                     <a:solidFill>
-                      <a:srgbClr val="D9F2D0"/>
+                      <a:schemeClr val="bg1"/>
                     </a:solidFill>
                   </a:tcPr>
                 </a:tc>
@@ -4650,16 +4586,13 @@
                       <a:pPr algn="ctr" rtl="0" fontAlgn="b">
                         <a:buNone/>
                       </a:pPr>
-                      <a:r>
-                        <a:rPr lang="en-US" sz="2000" b="1" i="0" u="none" strike="noStrike">
-                          <a:solidFill>
-                            <a:srgbClr val="000000"/>
-                          </a:solidFill>
-                          <a:effectLst/>
-                          <a:latin typeface="Aptos Narrow" panose="020B0004020202020204" pitchFamily="34" charset="0"/>
-                        </a:rPr>
-                        <a:t>212X9</a:t>
-                      </a:r>
+                      <a:endParaRPr lang="en-US" sz="2000" b="1" i="0" u="none" strike="noStrike" dirty="0">
+                        <a:solidFill>
+                          <a:srgbClr val="000000"/>
+                        </a:solidFill>
+                        <a:effectLst/>
+                        <a:latin typeface="Aptos Narrow" panose="020B0004020202020204" pitchFamily="34" charset="0"/>
+                      </a:endParaRPr>
                     </a:p>
                   </a:txBody>
                   <a:tcPr marL="6350" marR="6350" marT="6350" marB="0" anchor="ctr">
@@ -4700,9 +4633,7 @@
                       <a:tailEnd type="none" w="med" len="med"/>
                     </a:lnB>
                     <a:solidFill>
-                      <a:schemeClr val="bg2">
-                        <a:lumMod val="90000"/>
-                      </a:schemeClr>
+                      <a:schemeClr val="bg1"/>
                     </a:solidFill>
                   </a:tcPr>
                 </a:tc>
@@ -4714,16 +4645,13 @@
                       <a:pPr algn="ctr" rtl="0" fontAlgn="b">
                         <a:buNone/>
                       </a:pPr>
-                      <a:r>
-                        <a:rPr lang="en-US" sz="2000" b="1" i="0" u="none" strike="noStrike">
-                          <a:solidFill>
-                            <a:srgbClr val="000000"/>
-                          </a:solidFill>
-                          <a:effectLst/>
-                          <a:latin typeface="Aptos Narrow" panose="020B0004020202020204" pitchFamily="34" charset="0"/>
-                        </a:rPr>
-                        <a:t>212X10</a:t>
-                      </a:r>
+                      <a:endParaRPr lang="en-US" sz="2000" b="1" i="0" u="none" strike="noStrike" dirty="0">
+                        <a:solidFill>
+                          <a:srgbClr val="000000"/>
+                        </a:solidFill>
+                        <a:effectLst/>
+                        <a:latin typeface="Aptos Narrow" panose="020B0004020202020204" pitchFamily="34" charset="0"/>
+                      </a:endParaRPr>
                     </a:p>
                   </a:txBody>
                   <a:tcPr marL="6350" marR="6350" marT="6350" marB="0" anchor="ctr">
@@ -4763,7 +4691,9 @@
                       <a:headEnd type="none" w="med" len="med"/>
                       <a:tailEnd type="none" w="med" len="med"/>
                     </a:lnB>
-                    <a:noFill/>
+                    <a:solidFill>
+                      <a:schemeClr val="bg1"/>
+                    </a:solidFill>
                   </a:tcPr>
                 </a:tc>
                 <a:tc>
@@ -4774,16 +4704,13 @@
                       <a:pPr algn="ctr" rtl="0" fontAlgn="b">
                         <a:buNone/>
                       </a:pPr>
-                      <a:r>
-                        <a:rPr lang="en-US" sz="2000" b="1" i="0" u="none" strike="noStrike">
-                          <a:solidFill>
-                            <a:srgbClr val="000000"/>
-                          </a:solidFill>
-                          <a:effectLst/>
-                          <a:latin typeface="Aptos Narrow" panose="020B0004020202020204" pitchFamily="34" charset="0"/>
-                        </a:rPr>
-                        <a:t>212X11</a:t>
-                      </a:r>
+                      <a:endParaRPr lang="en-US" sz="2000" b="1" i="0" u="none" strike="noStrike" dirty="0">
+                        <a:solidFill>
+                          <a:srgbClr val="000000"/>
+                        </a:solidFill>
+                        <a:effectLst/>
+                        <a:latin typeface="Aptos Narrow" panose="020B0004020202020204" pitchFamily="34" charset="0"/>
+                      </a:endParaRPr>
                     </a:p>
                   </a:txBody>
                   <a:tcPr marL="6350" marR="6350" marT="6350" marB="0" anchor="ctr">
@@ -4823,67 +4750,9 @@
                       <a:headEnd type="none" w="med" len="med"/>
                       <a:tailEnd type="none" w="med" len="med"/>
                     </a:lnB>
-                    <a:noFill/>
-                  </a:tcPr>
-                </a:tc>
-                <a:tc>
-                  <a:txBody>
-                    <a:bodyPr/>
-                    <a:lstStyle/>
-                    <a:p>
-                      <a:pPr algn="ctr" rtl="0" fontAlgn="b">
-                        <a:buNone/>
-                      </a:pPr>
-                      <a:r>
-                        <a:rPr lang="en-US" sz="2000" b="1" i="0" u="none" strike="noStrike">
-                          <a:solidFill>
-                            <a:srgbClr val="000000"/>
-                          </a:solidFill>
-                          <a:effectLst/>
-                          <a:latin typeface="Aptos Narrow" panose="020B0004020202020204" pitchFamily="34" charset="0"/>
-                        </a:rPr>
-                        <a:t>212X12</a:t>
-                      </a:r>
-                    </a:p>
-                  </a:txBody>
-                  <a:tcPr marL="6350" marR="6350" marT="6350" marB="0" anchor="ctr">
-                    <a:lnL w="12700" cap="flat" cmpd="sng" algn="ctr">
-                      <a:solidFill>
-                        <a:srgbClr val="000000"/>
-                      </a:solidFill>
-                      <a:prstDash val="solid"/>
-                      <a:round/>
-                      <a:headEnd type="none" w="med" len="med"/>
-                      <a:tailEnd type="none" w="med" len="med"/>
-                    </a:lnL>
-                    <a:lnR w="12700" cap="flat" cmpd="sng" algn="ctr">
-                      <a:solidFill>
-                        <a:srgbClr val="000000"/>
-                      </a:solidFill>
-                      <a:prstDash val="solid"/>
-                      <a:round/>
-                      <a:headEnd type="none" w="med" len="med"/>
-                      <a:tailEnd type="none" w="med" len="med"/>
-                    </a:lnR>
-                    <a:lnT w="12700" cap="flat" cmpd="sng" algn="ctr">
-                      <a:solidFill>
-                        <a:srgbClr val="000000"/>
-                      </a:solidFill>
-                      <a:prstDash val="solid"/>
-                      <a:round/>
-                      <a:headEnd type="none" w="med" len="med"/>
-                      <a:tailEnd type="none" w="med" len="med"/>
-                    </a:lnT>
-                    <a:lnB w="12700" cap="flat" cmpd="sng" algn="ctr">
-                      <a:solidFill>
-                        <a:srgbClr val="000000"/>
-                      </a:solidFill>
-                      <a:prstDash val="solid"/>
-                      <a:round/>
-                      <a:headEnd type="none" w="med" len="med"/>
-                      <a:tailEnd type="none" w="med" len="med"/>
-                    </a:lnB>
-                    <a:noFill/>
+                    <a:solidFill>
+                      <a:schemeClr val="bg1"/>
+                    </a:solidFill>
                   </a:tcPr>
                 </a:tc>
                 <a:extLst>
@@ -4892,7 +4761,7 @@
                   </a:ext>
                 </a:extLst>
               </a:tr>
-              <a:tr h="712488">
+              <a:tr h="849485">
                 <a:tc gridSpan="3">
                   <a:txBody>
                     <a:bodyPr/>
@@ -4902,14 +4771,14 @@
                         <a:buNone/>
                       </a:pPr>
                       <a:r>
-                        <a:rPr lang="en-US" sz="1600" b="1" i="0" u="none" strike="noStrike">
+                        <a:rPr lang="en-US" sz="1600" b="1" i="0" u="none" strike="noStrike" dirty="0">
                           <a:solidFill>
                             <a:srgbClr val="000000"/>
                           </a:solidFill>
                           <a:effectLst/>
                           <a:latin typeface="Aptos Narrow" panose="020B0004020202020204" pitchFamily="34" charset="0"/>
                         </a:rPr>
-                        <a:t>Starting material  % Monomer</a:t>
+                        <a:t>%Monomer (Starting Material)</a:t>
                       </a:r>
                     </a:p>
                   </a:txBody>
@@ -4981,16 +4850,13 @@
                       <a:pPr algn="ctr" rtl="0" fontAlgn="b">
                         <a:buNone/>
                       </a:pPr>
-                      <a:r>
-                        <a:rPr lang="en-US" sz="2000" b="0" i="0" u="none" strike="noStrike">
-                          <a:solidFill>
-                            <a:srgbClr val="000000"/>
-                          </a:solidFill>
-                          <a:effectLst/>
-                          <a:latin typeface="Aptos Narrow" panose="020B0004020202020204" pitchFamily="34" charset="0"/>
-                        </a:rPr>
-                        <a:t>87</a:t>
-                      </a:r>
+                      <a:endParaRPr lang="en-US" sz="2000" b="0" i="0" u="none" strike="noStrike" dirty="0">
+                        <a:solidFill>
+                          <a:srgbClr val="000000"/>
+                        </a:solidFill>
+                        <a:effectLst/>
+                        <a:latin typeface="Aptos Narrow" panose="020B0004020202020204" pitchFamily="34" charset="0"/>
+                      </a:endParaRPr>
                     </a:p>
                   </a:txBody>
                   <a:tcPr marL="6350" marR="6350" marT="6350" marB="0" anchor="ctr">
@@ -5031,7 +4897,7 @@
                       <a:tailEnd type="none" w="med" len="med"/>
                     </a:lnB>
                     <a:solidFill>
-                      <a:srgbClr val="FBE3D6"/>
+                      <a:schemeClr val="bg1"/>
                     </a:solidFill>
                   </a:tcPr>
                 </a:tc>
@@ -5043,16 +4909,13 @@
                       <a:pPr algn="ctr" rtl="0" fontAlgn="b">
                         <a:buNone/>
                       </a:pPr>
-                      <a:r>
-                        <a:rPr lang="en-US" sz="2000" b="0" i="0" u="none" strike="noStrike">
-                          <a:solidFill>
-                            <a:srgbClr val="000000"/>
-                          </a:solidFill>
-                          <a:effectLst/>
-                          <a:latin typeface="Aptos Narrow" panose="020B0004020202020204" pitchFamily="34" charset="0"/>
-                        </a:rPr>
-                        <a:t>92</a:t>
-                      </a:r>
+                      <a:endParaRPr lang="en-US" sz="2000" b="0" i="0" u="none" strike="noStrike" dirty="0">
+                        <a:solidFill>
+                          <a:srgbClr val="000000"/>
+                        </a:solidFill>
+                        <a:effectLst/>
+                        <a:latin typeface="Aptos Narrow" panose="020B0004020202020204" pitchFamily="34" charset="0"/>
+                      </a:endParaRPr>
                     </a:p>
                   </a:txBody>
                   <a:tcPr marL="6350" marR="6350" marT="6350" marB="0" anchor="ctr">
@@ -5093,7 +4956,7 @@
                       <a:tailEnd type="none" w="med" len="med"/>
                     </a:lnB>
                     <a:solidFill>
-                      <a:srgbClr val="FBE3D6"/>
+                      <a:schemeClr val="bg1"/>
                     </a:solidFill>
                   </a:tcPr>
                 </a:tc>
@@ -5105,16 +4968,13 @@
                       <a:pPr algn="ctr" rtl="0" fontAlgn="b">
                         <a:buNone/>
                       </a:pPr>
-                      <a:r>
-                        <a:rPr lang="en-US" sz="2000" b="0" i="0" u="none" strike="noStrike">
-                          <a:solidFill>
-                            <a:srgbClr val="000000"/>
-                          </a:solidFill>
-                          <a:effectLst/>
-                          <a:latin typeface="Aptos Narrow" panose="020B0004020202020204" pitchFamily="34" charset="0"/>
-                        </a:rPr>
-                        <a:t>83</a:t>
-                      </a:r>
+                      <a:endParaRPr lang="en-US" sz="2000" b="0" i="0" u="none" strike="noStrike" dirty="0">
+                        <a:solidFill>
+                          <a:srgbClr val="000000"/>
+                        </a:solidFill>
+                        <a:effectLst/>
+                        <a:latin typeface="Aptos Narrow" panose="020B0004020202020204" pitchFamily="34" charset="0"/>
+                      </a:endParaRPr>
                     </a:p>
                   </a:txBody>
                   <a:tcPr marL="6350" marR="6350" marT="6350" marB="0" anchor="ctr">
@@ -5155,7 +5015,7 @@
                       <a:tailEnd type="none" w="med" len="med"/>
                     </a:lnB>
                     <a:solidFill>
-                      <a:srgbClr val="D9F2D0"/>
+                      <a:schemeClr val="bg1"/>
                     </a:solidFill>
                   </a:tcPr>
                 </a:tc>
@@ -5167,16 +5027,13 @@
                       <a:pPr algn="ctr" rtl="0" fontAlgn="b">
                         <a:buNone/>
                       </a:pPr>
-                      <a:r>
-                        <a:rPr lang="en-US" sz="2000" b="0" i="0" u="none" strike="noStrike">
-                          <a:solidFill>
-                            <a:srgbClr val="000000"/>
-                          </a:solidFill>
-                          <a:effectLst/>
-                          <a:latin typeface="Aptos Narrow" panose="020B0004020202020204" pitchFamily="34" charset="0"/>
-                        </a:rPr>
-                        <a:t>94</a:t>
-                      </a:r>
+                      <a:endParaRPr lang="en-US" sz="2000" b="0" i="0" u="none" strike="noStrike" dirty="0">
+                        <a:solidFill>
+                          <a:srgbClr val="000000"/>
+                        </a:solidFill>
+                        <a:effectLst/>
+                        <a:latin typeface="Aptos Narrow" panose="020B0004020202020204" pitchFamily="34" charset="0"/>
+                      </a:endParaRPr>
                     </a:p>
                   </a:txBody>
                   <a:tcPr marL="6350" marR="6350" marT="6350" marB="0" anchor="ctr">
@@ -5217,9 +5074,7 @@
                       <a:tailEnd type="none" w="med" len="med"/>
                     </a:lnB>
                     <a:solidFill>
-                      <a:schemeClr val="bg2">
-                        <a:lumMod val="90000"/>
-                      </a:schemeClr>
+                      <a:schemeClr val="bg1"/>
                     </a:solidFill>
                   </a:tcPr>
                 </a:tc>
@@ -5231,16 +5086,13 @@
                       <a:pPr algn="ctr" rtl="0" fontAlgn="b">
                         <a:buNone/>
                       </a:pPr>
-                      <a:r>
-                        <a:rPr lang="en-US" sz="2000" b="0" i="0" u="none" strike="noStrike">
-                          <a:solidFill>
-                            <a:srgbClr val="000000"/>
-                          </a:solidFill>
-                          <a:effectLst/>
-                          <a:latin typeface="Aptos Narrow" panose="020B0004020202020204" pitchFamily="34" charset="0"/>
-                        </a:rPr>
-                        <a:t>88</a:t>
-                      </a:r>
+                      <a:endParaRPr lang="en-US" sz="2000" b="0" i="0" u="none" strike="noStrike" dirty="0">
+                        <a:solidFill>
+                          <a:srgbClr val="000000"/>
+                        </a:solidFill>
+                        <a:effectLst/>
+                        <a:latin typeface="Aptos Narrow" panose="020B0004020202020204" pitchFamily="34" charset="0"/>
+                      </a:endParaRPr>
                     </a:p>
                   </a:txBody>
                   <a:tcPr marL="6350" marR="6350" marT="6350" marB="0" anchor="ctr">
@@ -5281,7 +5133,7 @@
                       <a:tailEnd type="none" w="med" len="med"/>
                     </a:lnB>
                     <a:solidFill>
-                      <a:srgbClr val="C04F15"/>
+                      <a:schemeClr val="bg1"/>
                     </a:solidFill>
                   </a:tcPr>
                 </a:tc>
@@ -5293,16 +5145,13 @@
                       <a:pPr algn="ctr" rtl="0" fontAlgn="b">
                         <a:buNone/>
                       </a:pPr>
-                      <a:r>
-                        <a:rPr lang="en-US" sz="2000" b="0" i="0" u="none" strike="noStrike">
-                          <a:solidFill>
-                            <a:srgbClr val="000000"/>
-                          </a:solidFill>
-                          <a:effectLst/>
-                          <a:latin typeface="Aptos Narrow" panose="020B0004020202020204" pitchFamily="34" charset="0"/>
-                        </a:rPr>
-                        <a:t>90</a:t>
-                      </a:r>
+                      <a:endParaRPr lang="en-US" sz="2000" b="0" i="0" u="none" strike="noStrike" dirty="0">
+                        <a:solidFill>
+                          <a:srgbClr val="000000"/>
+                        </a:solidFill>
+                        <a:effectLst/>
+                        <a:latin typeface="Aptos Narrow" panose="020B0004020202020204" pitchFamily="34" charset="0"/>
+                      </a:endParaRPr>
                     </a:p>
                   </a:txBody>
                   <a:tcPr marL="6350" marR="6350" marT="6350" marB="0" anchor="ctr">
@@ -5343,69 +5192,7 @@
                       <a:tailEnd type="none" w="med" len="med"/>
                     </a:lnB>
                     <a:solidFill>
-                      <a:srgbClr val="C04F15"/>
-                    </a:solidFill>
-                  </a:tcPr>
-                </a:tc>
-                <a:tc>
-                  <a:txBody>
-                    <a:bodyPr/>
-                    <a:lstStyle/>
-                    <a:p>
-                      <a:pPr algn="ctr" rtl="0" fontAlgn="b">
-                        <a:buNone/>
-                      </a:pPr>
-                      <a:r>
-                        <a:rPr lang="en-US" sz="2000" b="0" i="0" u="none" strike="noStrike">
-                          <a:solidFill>
-                            <a:srgbClr val="000000"/>
-                          </a:solidFill>
-                          <a:effectLst/>
-                          <a:latin typeface="Aptos Narrow" panose="020B0004020202020204" pitchFamily="34" charset="0"/>
-                        </a:rPr>
-                        <a:t>92</a:t>
-                      </a:r>
-                    </a:p>
-                  </a:txBody>
-                  <a:tcPr marL="6350" marR="6350" marT="6350" marB="0" anchor="ctr">
-                    <a:lnL w="12700" cap="flat" cmpd="sng" algn="ctr">
-                      <a:solidFill>
-                        <a:srgbClr val="000000"/>
-                      </a:solidFill>
-                      <a:prstDash val="solid"/>
-                      <a:round/>
-                      <a:headEnd type="none" w="med" len="med"/>
-                      <a:tailEnd type="none" w="med" len="med"/>
-                    </a:lnL>
-                    <a:lnR w="12700" cap="flat" cmpd="sng" algn="ctr">
-                      <a:solidFill>
-                        <a:srgbClr val="000000"/>
-                      </a:solidFill>
-                      <a:prstDash val="solid"/>
-                      <a:round/>
-                      <a:headEnd type="none" w="med" len="med"/>
-                      <a:tailEnd type="none" w="med" len="med"/>
-                    </a:lnR>
-                    <a:lnT w="12700" cap="flat" cmpd="sng" algn="ctr">
-                      <a:solidFill>
-                        <a:srgbClr val="000000"/>
-                      </a:solidFill>
-                      <a:prstDash val="solid"/>
-                      <a:round/>
-                      <a:headEnd type="none" w="med" len="med"/>
-                      <a:tailEnd type="none" w="med" len="med"/>
-                    </a:lnT>
-                    <a:lnB w="12700" cap="flat" cmpd="sng" algn="ctr">
-                      <a:solidFill>
-                        <a:srgbClr val="000000"/>
-                      </a:solidFill>
-                      <a:prstDash val="solid"/>
-                      <a:round/>
-                      <a:headEnd type="none" w="med" len="med"/>
-                      <a:tailEnd type="none" w="med" len="med"/>
-                    </a:lnB>
-                    <a:solidFill>
-                      <a:srgbClr val="C04F15"/>
+                      <a:schemeClr val="bg1"/>
                     </a:solidFill>
                   </a:tcPr>
                 </a:tc>
@@ -5415,7 +5202,7 @@
                   </a:ext>
                 </a:extLst>
               </a:tr>
-              <a:tr h="712488">
+              <a:tr h="849485">
                 <a:tc rowSpan="3">
                   <a:txBody>
                     <a:bodyPr/>
@@ -5425,7 +5212,7 @@
                         <a:buNone/>
                       </a:pPr>
                       <a:r>
-                        <a:rPr lang="en-US" sz="1600" b="1" i="0" u="none" strike="noStrike">
+                        <a:rPr lang="en-US" sz="1600" b="1" i="0" u="none" strike="noStrike" dirty="0">
                           <a:solidFill>
                             <a:srgbClr val="000000"/>
                           </a:solidFill>
@@ -5485,14 +5272,14 @@
                         <a:buNone/>
                       </a:pPr>
                       <a:r>
-                        <a:rPr lang="en-US" sz="1600" b="1" i="0" u="none" strike="noStrike">
+                        <a:rPr lang="en-US" sz="1600" b="1" i="0" u="none" strike="noStrike" dirty="0">
                           <a:solidFill>
                             <a:srgbClr val="000000"/>
                           </a:solidFill>
                           <a:effectLst/>
                           <a:latin typeface="Aptos Narrow" panose="020B0004020202020204" pitchFamily="34" charset="0"/>
                         </a:rPr>
-                        <a:t>Monomer% in Plasma</a:t>
+                        <a:t>%Monomer (Plasma)</a:t>
                       </a:r>
                     </a:p>
                   </a:txBody>
@@ -5545,7 +5332,7 @@
                         <a:buNone/>
                       </a:pPr>
                       <a:r>
-                        <a:rPr lang="en-US" sz="1600" b="1" i="0" u="none" strike="noStrike">
+                        <a:rPr lang="en-US" sz="1600" b="1" i="0" u="none" strike="noStrike" dirty="0">
                           <a:solidFill>
                             <a:srgbClr val="000000"/>
                           </a:solidFill>
@@ -5604,16 +5391,13 @@
                       <a:pPr algn="ctr" rtl="0" fontAlgn="b">
                         <a:buNone/>
                       </a:pPr>
-                      <a:r>
-                        <a:rPr lang="en-US" sz="2000" b="0" i="0" u="none" strike="noStrike">
-                          <a:solidFill>
-                            <a:srgbClr val="000000"/>
-                          </a:solidFill>
-                          <a:effectLst/>
-                          <a:latin typeface="Aptos Narrow" panose="020B0004020202020204" pitchFamily="34" charset="0"/>
-                        </a:rPr>
-                        <a:t>71</a:t>
-                      </a:r>
+                      <a:endParaRPr lang="en-US" sz="2000" b="0" i="0" u="none" strike="noStrike" dirty="0">
+                        <a:solidFill>
+                          <a:srgbClr val="000000"/>
+                        </a:solidFill>
+                        <a:effectLst/>
+                        <a:latin typeface="Aptos Narrow" panose="020B0004020202020204" pitchFamily="34" charset="0"/>
+                      </a:endParaRPr>
                     </a:p>
                   </a:txBody>
                   <a:tcPr marL="6350" marR="6350" marT="6350" marB="0" anchor="ctr">
@@ -5654,7 +5438,7 @@
                       <a:tailEnd type="none" w="med" len="med"/>
                     </a:lnB>
                     <a:solidFill>
-                      <a:srgbClr val="FBE3D6"/>
+                      <a:schemeClr val="bg1"/>
                     </a:solidFill>
                   </a:tcPr>
                 </a:tc>
@@ -5666,16 +5450,13 @@
                       <a:pPr algn="ctr" rtl="0" fontAlgn="b">
                         <a:buNone/>
                       </a:pPr>
-                      <a:r>
-                        <a:rPr lang="en-US" sz="2000" b="0" i="0" u="none" strike="noStrike">
-                          <a:solidFill>
-                            <a:srgbClr val="000000"/>
-                          </a:solidFill>
-                          <a:effectLst/>
-                          <a:latin typeface="Aptos Narrow" panose="020B0004020202020204" pitchFamily="34" charset="0"/>
-                        </a:rPr>
-                        <a:t>83</a:t>
-                      </a:r>
+                      <a:endParaRPr lang="en-US" sz="2000" b="0" i="0" u="none" strike="noStrike" dirty="0">
+                        <a:solidFill>
+                          <a:srgbClr val="000000"/>
+                        </a:solidFill>
+                        <a:effectLst/>
+                        <a:latin typeface="Aptos Narrow" panose="020B0004020202020204" pitchFamily="34" charset="0"/>
+                      </a:endParaRPr>
                     </a:p>
                   </a:txBody>
                   <a:tcPr marL="6350" marR="6350" marT="6350" marB="0" anchor="ctr">
@@ -5716,7 +5497,7 @@
                       <a:tailEnd type="none" w="med" len="med"/>
                     </a:lnB>
                     <a:solidFill>
-                      <a:srgbClr val="FBE3D6"/>
+                      <a:schemeClr val="bg1"/>
                     </a:solidFill>
                   </a:tcPr>
                 </a:tc>
@@ -5728,16 +5509,13 @@
                       <a:pPr algn="ctr" rtl="0" fontAlgn="b">
                         <a:buNone/>
                       </a:pPr>
-                      <a:r>
-                        <a:rPr lang="en-US" sz="2000" b="0" i="0" u="none" strike="noStrike">
-                          <a:solidFill>
-                            <a:srgbClr val="000000"/>
-                          </a:solidFill>
-                          <a:effectLst/>
-                          <a:latin typeface="Aptos Narrow" panose="020B0004020202020204" pitchFamily="34" charset="0"/>
-                        </a:rPr>
-                        <a:t>83</a:t>
-                      </a:r>
+                      <a:endParaRPr lang="en-US" sz="2000" b="0" i="0" u="none" strike="noStrike" dirty="0">
+                        <a:solidFill>
+                          <a:srgbClr val="000000"/>
+                        </a:solidFill>
+                        <a:effectLst/>
+                        <a:latin typeface="Aptos Narrow" panose="020B0004020202020204" pitchFamily="34" charset="0"/>
+                      </a:endParaRPr>
                     </a:p>
                   </a:txBody>
                   <a:tcPr marL="6350" marR="6350" marT="6350" marB="0" anchor="ctr">
@@ -5778,7 +5556,7 @@
                       <a:tailEnd type="none" w="med" len="med"/>
                     </a:lnB>
                     <a:solidFill>
-                      <a:srgbClr val="D9F2D0"/>
+                      <a:schemeClr val="bg1"/>
                     </a:solidFill>
                   </a:tcPr>
                 </a:tc>
@@ -5790,16 +5568,13 @@
                       <a:pPr algn="ctr" rtl="0" fontAlgn="b">
                         <a:buNone/>
                       </a:pPr>
-                      <a:r>
-                        <a:rPr lang="en-US" sz="2000" b="0" i="0" u="none" strike="noStrike">
-                          <a:solidFill>
-                            <a:srgbClr val="000000"/>
-                          </a:solidFill>
-                          <a:effectLst/>
-                          <a:latin typeface="Aptos Narrow" panose="020B0004020202020204" pitchFamily="34" charset="0"/>
-                        </a:rPr>
-                        <a:t>72</a:t>
-                      </a:r>
+                      <a:endParaRPr lang="en-US" sz="2000" b="0" i="0" u="none" strike="noStrike" dirty="0">
+                        <a:solidFill>
+                          <a:srgbClr val="000000"/>
+                        </a:solidFill>
+                        <a:effectLst/>
+                        <a:latin typeface="Aptos Narrow" panose="020B0004020202020204" pitchFamily="34" charset="0"/>
+                      </a:endParaRPr>
                     </a:p>
                   </a:txBody>
                   <a:tcPr marL="6350" marR="6350" marT="6350" marB="0" anchor="ctr">
@@ -5840,9 +5615,7 @@
                       <a:tailEnd type="none" w="med" len="med"/>
                     </a:lnB>
                     <a:solidFill>
-                      <a:schemeClr val="bg2">
-                        <a:lumMod val="90000"/>
-                      </a:schemeClr>
+                      <a:schemeClr val="bg1"/>
                     </a:solidFill>
                   </a:tcPr>
                 </a:tc>
@@ -5854,16 +5627,13 @@
                       <a:pPr algn="ctr" rtl="0" fontAlgn="b">
                         <a:buNone/>
                       </a:pPr>
-                      <a:r>
-                        <a:rPr lang="en-US" sz="2000" b="0" i="0" u="none" strike="noStrike">
-                          <a:solidFill>
-                            <a:srgbClr val="000000"/>
-                          </a:solidFill>
-                          <a:effectLst/>
-                          <a:latin typeface="Aptos Narrow" panose="020B0004020202020204" pitchFamily="34" charset="0"/>
-                        </a:rPr>
-                        <a:t>69</a:t>
-                      </a:r>
+                      <a:endParaRPr lang="en-US" sz="2000" b="0" i="0" u="none" strike="noStrike">
+                        <a:solidFill>
+                          <a:srgbClr val="000000"/>
+                        </a:solidFill>
+                        <a:effectLst/>
+                        <a:latin typeface="Aptos Narrow" panose="020B0004020202020204" pitchFamily="34" charset="0"/>
+                      </a:endParaRPr>
                     </a:p>
                   </a:txBody>
                   <a:tcPr marL="6350" marR="6350" marT="6350" marB="0" anchor="ctr">
@@ -5904,7 +5674,7 @@
                       <a:tailEnd type="none" w="med" len="med"/>
                     </a:lnB>
                     <a:solidFill>
-                      <a:srgbClr val="C04F15"/>
+                      <a:schemeClr val="bg1"/>
                     </a:solidFill>
                   </a:tcPr>
                 </a:tc>
@@ -5916,16 +5686,13 @@
                       <a:pPr algn="ctr" rtl="0" fontAlgn="b">
                         <a:buNone/>
                       </a:pPr>
-                      <a:r>
-                        <a:rPr lang="en-US" sz="2000" b="0" i="0" u="none" strike="noStrike">
-                          <a:solidFill>
-                            <a:srgbClr val="000000"/>
-                          </a:solidFill>
-                          <a:effectLst/>
-                          <a:latin typeface="Aptos Narrow" panose="020B0004020202020204" pitchFamily="34" charset="0"/>
-                        </a:rPr>
-                        <a:t>70</a:t>
-                      </a:r>
+                      <a:endParaRPr lang="en-US" sz="2000" b="0" i="0" u="none" strike="noStrike" dirty="0">
+                        <a:solidFill>
+                          <a:srgbClr val="000000"/>
+                        </a:solidFill>
+                        <a:effectLst/>
+                        <a:latin typeface="Aptos Narrow" panose="020B0004020202020204" pitchFamily="34" charset="0"/>
+                      </a:endParaRPr>
                     </a:p>
                   </a:txBody>
                   <a:tcPr marL="6350" marR="6350" marT="6350" marB="0" anchor="ctr">
@@ -5966,69 +5733,7 @@
                       <a:tailEnd type="none" w="med" len="med"/>
                     </a:lnB>
                     <a:solidFill>
-                      <a:srgbClr val="C04F15"/>
-                    </a:solidFill>
-                  </a:tcPr>
-                </a:tc>
-                <a:tc>
-                  <a:txBody>
-                    <a:bodyPr/>
-                    <a:lstStyle/>
-                    <a:p>
-                      <a:pPr algn="ctr" rtl="0" fontAlgn="b">
-                        <a:buNone/>
-                      </a:pPr>
-                      <a:r>
-                        <a:rPr lang="en-US" sz="2000" b="0" i="0" u="none" strike="noStrike">
-                          <a:solidFill>
-                            <a:srgbClr val="000000"/>
-                          </a:solidFill>
-                          <a:effectLst/>
-                          <a:latin typeface="Aptos Narrow" panose="020B0004020202020204" pitchFamily="34" charset="0"/>
-                        </a:rPr>
-                        <a:t>70</a:t>
-                      </a:r>
-                    </a:p>
-                  </a:txBody>
-                  <a:tcPr marL="6350" marR="6350" marT="6350" marB="0" anchor="ctr">
-                    <a:lnL w="12700" cap="flat" cmpd="sng" algn="ctr">
-                      <a:solidFill>
-                        <a:srgbClr val="000000"/>
-                      </a:solidFill>
-                      <a:prstDash val="solid"/>
-                      <a:round/>
-                      <a:headEnd type="none" w="med" len="med"/>
-                      <a:tailEnd type="none" w="med" len="med"/>
-                    </a:lnL>
-                    <a:lnR w="12700" cap="flat" cmpd="sng" algn="ctr">
-                      <a:solidFill>
-                        <a:srgbClr val="000000"/>
-                      </a:solidFill>
-                      <a:prstDash val="solid"/>
-                      <a:round/>
-                      <a:headEnd type="none" w="med" len="med"/>
-                      <a:tailEnd type="none" w="med" len="med"/>
-                    </a:lnR>
-                    <a:lnT w="12700" cap="flat" cmpd="sng" algn="ctr">
-                      <a:solidFill>
-                        <a:srgbClr val="000000"/>
-                      </a:solidFill>
-                      <a:prstDash val="solid"/>
-                      <a:round/>
-                      <a:headEnd type="none" w="med" len="med"/>
-                      <a:tailEnd type="none" w="med" len="med"/>
-                    </a:lnT>
-                    <a:lnB w="12700" cap="flat" cmpd="sng" algn="ctr">
-                      <a:solidFill>
-                        <a:srgbClr val="000000"/>
-                      </a:solidFill>
-                      <a:prstDash val="solid"/>
-                      <a:round/>
-                      <a:headEnd type="none" w="med" len="med"/>
-                      <a:tailEnd type="none" w="med" len="med"/>
-                    </a:lnB>
-                    <a:solidFill>
-                      <a:srgbClr val="C04F15"/>
+                      <a:schemeClr val="bg1"/>
                     </a:solidFill>
                   </a:tcPr>
                 </a:tc>
@@ -6038,7 +5743,7 @@
                   </a:ext>
                 </a:extLst>
               </a:tr>
-              <a:tr h="712488">
+              <a:tr h="849485">
                 <a:tc vMerge="1">
                   <a:txBody>
                     <a:bodyPr/>
@@ -6127,16 +5832,13 @@
                       <a:pPr algn="ctr" rtl="0" fontAlgn="b">
                         <a:buNone/>
                       </a:pPr>
-                      <a:r>
-                        <a:rPr lang="en-US" sz="2000" b="0" i="0" u="none" strike="noStrike">
-                          <a:solidFill>
-                            <a:srgbClr val="000000"/>
-                          </a:solidFill>
-                          <a:effectLst/>
-                          <a:latin typeface="Aptos Narrow" panose="020B0004020202020204" pitchFamily="34" charset="0"/>
-                        </a:rPr>
-                        <a:t>64</a:t>
-                      </a:r>
+                      <a:endParaRPr lang="en-US" sz="2000" b="0" i="0" u="none" strike="noStrike" dirty="0">
+                        <a:solidFill>
+                          <a:srgbClr val="000000"/>
+                        </a:solidFill>
+                        <a:effectLst/>
+                        <a:latin typeface="Aptos Narrow" panose="020B0004020202020204" pitchFamily="34" charset="0"/>
+                      </a:endParaRPr>
                     </a:p>
                   </a:txBody>
                   <a:tcPr marL="6350" marR="6350" marT="6350" marB="0" anchor="ctr">
@@ -6176,128 +5878,8 @@
                       <a:headEnd type="none" w="med" len="med"/>
                       <a:tailEnd type="none" w="med" len="med"/>
                     </a:lnB>
-                    <a:noFill/>
-                  </a:tcPr>
-                </a:tc>
-                <a:tc>
-                  <a:txBody>
-                    <a:bodyPr/>
-                    <a:lstStyle/>
-                    <a:p>
-                      <a:pPr algn="ctr" rtl="0" fontAlgn="b">
-                        <a:buNone/>
-                      </a:pPr>
-                      <a:r>
-                        <a:rPr lang="en-US" sz="2000" b="0" i="0" u="none" strike="noStrike">
-                          <a:solidFill>
-                            <a:srgbClr val="000000"/>
-                          </a:solidFill>
-                          <a:effectLst/>
-                          <a:latin typeface="Aptos Narrow" panose="020B0004020202020204" pitchFamily="34" charset="0"/>
-                        </a:rPr>
-                        <a:t>80</a:t>
-                      </a:r>
-                    </a:p>
-                  </a:txBody>
-                  <a:tcPr marL="6350" marR="6350" marT="6350" marB="0" anchor="ctr">
-                    <a:lnL w="12700" cap="flat" cmpd="sng" algn="ctr">
-                      <a:solidFill>
-                        <a:srgbClr val="000000"/>
-                      </a:solidFill>
-                      <a:prstDash val="solid"/>
-                      <a:round/>
-                      <a:headEnd type="none" w="med" len="med"/>
-                      <a:tailEnd type="none" w="med" len="med"/>
-                    </a:lnL>
-                    <a:lnR w="12700" cap="flat" cmpd="sng" algn="ctr">
-                      <a:solidFill>
-                        <a:srgbClr val="000000"/>
-                      </a:solidFill>
-                      <a:prstDash val="solid"/>
-                      <a:round/>
-                      <a:headEnd type="none" w="med" len="med"/>
-                      <a:tailEnd type="none" w="med" len="med"/>
-                    </a:lnR>
-                    <a:lnT w="12700" cap="flat" cmpd="sng" algn="ctr">
-                      <a:solidFill>
-                        <a:srgbClr val="000000"/>
-                      </a:solidFill>
-                      <a:prstDash val="solid"/>
-                      <a:round/>
-                      <a:headEnd type="none" w="med" len="med"/>
-                      <a:tailEnd type="none" w="med" len="med"/>
-                    </a:lnT>
-                    <a:lnB w="12700" cap="flat" cmpd="sng" algn="ctr">
-                      <a:solidFill>
-                        <a:srgbClr val="000000"/>
-                      </a:solidFill>
-                      <a:prstDash val="solid"/>
-                      <a:round/>
-                      <a:headEnd type="none" w="med" len="med"/>
-                      <a:tailEnd type="none" w="med" len="med"/>
-                    </a:lnB>
-                    <a:noFill/>
-                  </a:tcPr>
-                </a:tc>
-                <a:tc>
-                  <a:txBody>
-                    <a:bodyPr/>
-                    <a:lstStyle/>
-                    <a:p>
-                      <a:pPr algn="ctr" rtl="0" fontAlgn="b">
-                        <a:buNone/>
-                      </a:pPr>
-                      <a:r>
-                        <a:rPr lang="en-US" sz="2000" b="0" i="0" u="none" strike="noStrike">
-                          <a:solidFill>
-                            <a:srgbClr val="000000"/>
-                          </a:solidFill>
-                          <a:effectLst/>
-                          <a:latin typeface="Aptos Narrow" panose="020B0004020202020204" pitchFamily="34" charset="0"/>
-                        </a:rPr>
-                        <a:t>87</a:t>
-                      </a:r>
-                    </a:p>
-                  </a:txBody>
-                  <a:tcPr marL="6350" marR="6350" marT="6350" marB="0" anchor="ctr">
-                    <a:lnL w="12700" cap="flat" cmpd="sng" algn="ctr">
-                      <a:solidFill>
-                        <a:srgbClr val="000000"/>
-                      </a:solidFill>
-                      <a:prstDash val="solid"/>
-                      <a:round/>
-                      <a:headEnd type="none" w="med" len="med"/>
-                      <a:tailEnd type="none" w="med" len="med"/>
-                    </a:lnL>
-                    <a:lnR w="12700" cap="flat" cmpd="sng" algn="ctr">
-                      <a:solidFill>
-                        <a:srgbClr val="000000"/>
-                      </a:solidFill>
-                      <a:prstDash val="solid"/>
-                      <a:round/>
-                      <a:headEnd type="none" w="med" len="med"/>
-                      <a:tailEnd type="none" w="med" len="med"/>
-                    </a:lnR>
-                    <a:lnT w="12700" cap="flat" cmpd="sng" algn="ctr">
-                      <a:solidFill>
-                        <a:srgbClr val="000000"/>
-                      </a:solidFill>
-                      <a:prstDash val="solid"/>
-                      <a:round/>
-                      <a:headEnd type="none" w="med" len="med"/>
-                      <a:tailEnd type="none" w="med" len="med"/>
-                    </a:lnT>
-                    <a:lnB w="12700" cap="flat" cmpd="sng" algn="ctr">
-                      <a:solidFill>
-                        <a:srgbClr val="000000"/>
-                      </a:solidFill>
-                      <a:prstDash val="solid"/>
-                      <a:round/>
-                      <a:headEnd type="none" w="med" len="med"/>
-                      <a:tailEnd type="none" w="med" len="med"/>
-                    </a:lnB>
                     <a:solidFill>
-                      <a:srgbClr val="D9F2D0"/>
+                      <a:schemeClr val="bg1"/>
                     </a:solidFill>
                   </a:tcPr>
                 </a:tc>
@@ -6309,16 +5891,13 @@
                       <a:pPr algn="ctr" rtl="0" fontAlgn="b">
                         <a:buNone/>
                       </a:pPr>
-                      <a:r>
-                        <a:rPr lang="en-US" sz="2000" b="0" i="0" u="none" strike="noStrike">
-                          <a:solidFill>
-                            <a:srgbClr val="000000"/>
-                          </a:solidFill>
-                          <a:effectLst/>
-                          <a:latin typeface="Aptos Narrow" panose="020B0004020202020204" pitchFamily="34" charset="0"/>
-                        </a:rPr>
-                        <a:t>70</a:t>
-                      </a:r>
+                      <a:endParaRPr lang="en-US" sz="2000" b="0" i="0" u="none" strike="noStrike" dirty="0">
+                        <a:solidFill>
+                          <a:srgbClr val="000000"/>
+                        </a:solidFill>
+                        <a:effectLst/>
+                        <a:latin typeface="Aptos Narrow" panose="020B0004020202020204" pitchFamily="34" charset="0"/>
+                      </a:endParaRPr>
                     </a:p>
                   </a:txBody>
                   <a:tcPr marL="6350" marR="6350" marT="6350" marB="0" anchor="ctr">
@@ -6359,9 +5938,7 @@
                       <a:tailEnd type="none" w="med" len="med"/>
                     </a:lnB>
                     <a:solidFill>
-                      <a:schemeClr val="bg2">
-                        <a:lumMod val="90000"/>
-                      </a:schemeClr>
+                      <a:schemeClr val="bg1"/>
                     </a:solidFill>
                   </a:tcPr>
                 </a:tc>
@@ -6373,16 +5950,13 @@
                       <a:pPr algn="ctr" rtl="0" fontAlgn="b">
                         <a:buNone/>
                       </a:pPr>
-                      <a:r>
-                        <a:rPr lang="en-US" sz="2000" b="0" i="0" u="none" strike="noStrike">
-                          <a:solidFill>
-                            <a:srgbClr val="000000"/>
-                          </a:solidFill>
-                          <a:effectLst/>
-                          <a:latin typeface="Aptos Narrow" panose="020B0004020202020204" pitchFamily="34" charset="0"/>
-                        </a:rPr>
-                        <a:t>76</a:t>
-                      </a:r>
+                      <a:endParaRPr lang="en-US" sz="2000" b="0" i="0" u="none" strike="noStrike" dirty="0">
+                        <a:solidFill>
+                          <a:srgbClr val="000000"/>
+                        </a:solidFill>
+                        <a:effectLst/>
+                        <a:latin typeface="Aptos Narrow" panose="020B0004020202020204" pitchFamily="34" charset="0"/>
+                      </a:endParaRPr>
                     </a:p>
                   </a:txBody>
                   <a:tcPr marL="6350" marR="6350" marT="6350" marB="0" anchor="ctr">
@@ -6422,7 +5996,9 @@
                       <a:headEnd type="none" w="med" len="med"/>
                       <a:tailEnd type="none" w="med" len="med"/>
                     </a:lnB>
-                    <a:noFill/>
+                    <a:solidFill>
+                      <a:schemeClr val="bg1"/>
+                    </a:solidFill>
                   </a:tcPr>
                 </a:tc>
                 <a:tc>
@@ -6433,16 +6009,13 @@
                       <a:pPr algn="ctr" rtl="0" fontAlgn="b">
                         <a:buNone/>
                       </a:pPr>
-                      <a:r>
-                        <a:rPr lang="en-US" sz="2000" b="0" i="0" u="none" strike="noStrike">
-                          <a:solidFill>
-                            <a:srgbClr val="000000"/>
-                          </a:solidFill>
-                          <a:effectLst/>
-                          <a:latin typeface="Aptos Narrow" panose="020B0004020202020204" pitchFamily="34" charset="0"/>
-                        </a:rPr>
-                        <a:t>69</a:t>
-                      </a:r>
+                      <a:endParaRPr lang="en-US" sz="2000" b="0" i="0" u="none" strike="noStrike" dirty="0">
+                        <a:solidFill>
+                          <a:srgbClr val="000000"/>
+                        </a:solidFill>
+                        <a:effectLst/>
+                        <a:latin typeface="Aptos Narrow" panose="020B0004020202020204" pitchFamily="34" charset="0"/>
+                      </a:endParaRPr>
                     </a:p>
                   </a:txBody>
                   <a:tcPr marL="6350" marR="6350" marT="6350" marB="0" anchor="ctr">
@@ -6482,7 +6055,9 @@
                       <a:headEnd type="none" w="med" len="med"/>
                       <a:tailEnd type="none" w="med" len="med"/>
                     </a:lnB>
-                    <a:noFill/>
+                    <a:solidFill>
+                      <a:schemeClr val="bg1"/>
+                    </a:solidFill>
                   </a:tcPr>
                 </a:tc>
                 <a:tc>
@@ -6493,16 +6068,13 @@
                       <a:pPr algn="ctr" rtl="0" fontAlgn="b">
                         <a:buNone/>
                       </a:pPr>
-                      <a:r>
-                        <a:rPr lang="en-US" sz="2000" b="0" i="0" u="none" strike="noStrike">
-                          <a:solidFill>
-                            <a:srgbClr val="000000"/>
-                          </a:solidFill>
-                          <a:effectLst/>
-                          <a:latin typeface="Aptos Narrow" panose="020B0004020202020204" pitchFamily="34" charset="0"/>
-                        </a:rPr>
-                        <a:t>66</a:t>
-                      </a:r>
+                      <a:endParaRPr lang="en-US" sz="2000" b="0" i="0" u="none" strike="noStrike" dirty="0">
+                        <a:solidFill>
+                          <a:srgbClr val="000000"/>
+                        </a:solidFill>
+                        <a:effectLst/>
+                        <a:latin typeface="Aptos Narrow" panose="020B0004020202020204" pitchFamily="34" charset="0"/>
+                      </a:endParaRPr>
                     </a:p>
                   </a:txBody>
                   <a:tcPr marL="6350" marR="6350" marT="6350" marB="0" anchor="ctr">
@@ -6542,7 +6114,68 @@
                       <a:headEnd type="none" w="med" len="med"/>
                       <a:tailEnd type="none" w="med" len="med"/>
                     </a:lnB>
-                    <a:noFill/>
+                    <a:solidFill>
+                      <a:schemeClr val="bg1"/>
+                    </a:solidFill>
+                  </a:tcPr>
+                </a:tc>
+                <a:tc>
+                  <a:txBody>
+                    <a:bodyPr/>
+                    <a:lstStyle/>
+                    <a:p>
+                      <a:pPr algn="ctr" rtl="0" fontAlgn="b">
+                        <a:buNone/>
+                      </a:pPr>
+                      <a:endParaRPr lang="en-US" sz="2000" b="0" i="0" u="none" strike="noStrike" dirty="0">
+                        <a:solidFill>
+                          <a:srgbClr val="000000"/>
+                        </a:solidFill>
+                        <a:effectLst/>
+                        <a:latin typeface="Aptos Narrow" panose="020B0004020202020204" pitchFamily="34" charset="0"/>
+                      </a:endParaRPr>
+                    </a:p>
+                  </a:txBody>
+                  <a:tcPr marL="6350" marR="6350" marT="6350" marB="0" anchor="ctr">
+                    <a:lnL w="12700" cap="flat" cmpd="sng" algn="ctr">
+                      <a:solidFill>
+                        <a:srgbClr val="000000"/>
+                      </a:solidFill>
+                      <a:prstDash val="solid"/>
+                      <a:round/>
+                      <a:headEnd type="none" w="med" len="med"/>
+                      <a:tailEnd type="none" w="med" len="med"/>
+                    </a:lnL>
+                    <a:lnR w="12700" cap="flat" cmpd="sng" algn="ctr">
+                      <a:solidFill>
+                        <a:srgbClr val="000000"/>
+                      </a:solidFill>
+                      <a:prstDash val="solid"/>
+                      <a:round/>
+                      <a:headEnd type="none" w="med" len="med"/>
+                      <a:tailEnd type="none" w="med" len="med"/>
+                    </a:lnR>
+                    <a:lnT w="12700" cap="flat" cmpd="sng" algn="ctr">
+                      <a:solidFill>
+                        <a:srgbClr val="000000"/>
+                      </a:solidFill>
+                      <a:prstDash val="solid"/>
+                      <a:round/>
+                      <a:headEnd type="none" w="med" len="med"/>
+                      <a:tailEnd type="none" w="med" len="med"/>
+                    </a:lnT>
+                    <a:lnB w="12700" cap="flat" cmpd="sng" algn="ctr">
+                      <a:solidFill>
+                        <a:srgbClr val="000000"/>
+                      </a:solidFill>
+                      <a:prstDash val="solid"/>
+                      <a:round/>
+                      <a:headEnd type="none" w="med" len="med"/>
+                      <a:tailEnd type="none" w="med" len="med"/>
+                    </a:lnB>
+                    <a:solidFill>
+                      <a:schemeClr val="bg1"/>
+                    </a:solidFill>
                   </a:tcPr>
                 </a:tc>
                 <a:extLst>
@@ -6551,7 +6184,7 @@
                   </a:ext>
                 </a:extLst>
               </a:tr>
-              <a:tr h="712488">
+              <a:tr h="849485">
                 <a:tc vMerge="1">
                   <a:txBody>
                     <a:bodyPr/>
@@ -6640,16 +6273,13 @@
                       <a:pPr algn="ctr" rtl="0" fontAlgn="b">
                         <a:buNone/>
                       </a:pPr>
-                      <a:r>
-                        <a:rPr lang="en-US" sz="2000" b="0" i="0" u="none" strike="noStrike">
-                          <a:solidFill>
-                            <a:srgbClr val="000000"/>
-                          </a:solidFill>
-                          <a:effectLst/>
-                          <a:latin typeface="Aptos Narrow" panose="020B0004020202020204" pitchFamily="34" charset="0"/>
-                        </a:rPr>
-                        <a:t>59</a:t>
-                      </a:r>
+                      <a:endParaRPr lang="en-US" sz="2000" b="0" i="0" u="none" strike="noStrike">
+                        <a:solidFill>
+                          <a:srgbClr val="000000"/>
+                        </a:solidFill>
+                        <a:effectLst/>
+                        <a:latin typeface="Aptos Narrow" panose="020B0004020202020204" pitchFamily="34" charset="0"/>
+                      </a:endParaRPr>
                     </a:p>
                   </a:txBody>
                   <a:tcPr marL="6350" marR="6350" marT="6350" marB="0" anchor="ctr">
@@ -6689,128 +6319,8 @@
                       <a:headEnd type="none" w="med" len="med"/>
                       <a:tailEnd type="none" w="med" len="med"/>
                     </a:lnB>
-                    <a:noFill/>
-                  </a:tcPr>
-                </a:tc>
-                <a:tc>
-                  <a:txBody>
-                    <a:bodyPr/>
-                    <a:lstStyle/>
-                    <a:p>
-                      <a:pPr algn="ctr" rtl="0" fontAlgn="b">
-                        <a:buNone/>
-                      </a:pPr>
-                      <a:r>
-                        <a:rPr lang="en-US" sz="2000" b="0" i="0" u="none" strike="noStrike">
-                          <a:solidFill>
-                            <a:srgbClr val="000000"/>
-                          </a:solidFill>
-                          <a:effectLst/>
-                          <a:latin typeface="Aptos Narrow" panose="020B0004020202020204" pitchFamily="34" charset="0"/>
-                        </a:rPr>
-                        <a:t>68</a:t>
-                      </a:r>
-                    </a:p>
-                  </a:txBody>
-                  <a:tcPr marL="6350" marR="6350" marT="6350" marB="0" anchor="ctr">
-                    <a:lnL w="12700" cap="flat" cmpd="sng" algn="ctr">
-                      <a:solidFill>
-                        <a:srgbClr val="000000"/>
-                      </a:solidFill>
-                      <a:prstDash val="solid"/>
-                      <a:round/>
-                      <a:headEnd type="none" w="med" len="med"/>
-                      <a:tailEnd type="none" w="med" len="med"/>
-                    </a:lnL>
-                    <a:lnR w="12700" cap="flat" cmpd="sng" algn="ctr">
-                      <a:solidFill>
-                        <a:srgbClr val="000000"/>
-                      </a:solidFill>
-                      <a:prstDash val="solid"/>
-                      <a:round/>
-                      <a:headEnd type="none" w="med" len="med"/>
-                      <a:tailEnd type="none" w="med" len="med"/>
-                    </a:lnR>
-                    <a:lnT w="12700" cap="flat" cmpd="sng" algn="ctr">
-                      <a:solidFill>
-                        <a:srgbClr val="000000"/>
-                      </a:solidFill>
-                      <a:prstDash val="solid"/>
-                      <a:round/>
-                      <a:headEnd type="none" w="med" len="med"/>
-                      <a:tailEnd type="none" w="med" len="med"/>
-                    </a:lnT>
-                    <a:lnB w="12700" cap="flat" cmpd="sng" algn="ctr">
-                      <a:solidFill>
-                        <a:srgbClr val="000000"/>
-                      </a:solidFill>
-                      <a:prstDash val="solid"/>
-                      <a:round/>
-                      <a:headEnd type="none" w="med" len="med"/>
-                      <a:tailEnd type="none" w="med" len="med"/>
-                    </a:lnB>
-                    <a:noFill/>
-                  </a:tcPr>
-                </a:tc>
-                <a:tc>
-                  <a:txBody>
-                    <a:bodyPr/>
-                    <a:lstStyle/>
-                    <a:p>
-                      <a:pPr algn="ctr" rtl="0" fontAlgn="b">
-                        <a:buNone/>
-                      </a:pPr>
-                      <a:r>
-                        <a:rPr lang="en-US" sz="2000" b="0" i="0" u="none" strike="noStrike">
-                          <a:solidFill>
-                            <a:srgbClr val="000000"/>
-                          </a:solidFill>
-                          <a:effectLst/>
-                          <a:latin typeface="Aptos Narrow" panose="020B0004020202020204" pitchFamily="34" charset="0"/>
-                        </a:rPr>
-                        <a:t>86</a:t>
-                      </a:r>
-                    </a:p>
-                  </a:txBody>
-                  <a:tcPr marL="6350" marR="6350" marT="6350" marB="0" anchor="ctr">
-                    <a:lnL w="12700" cap="flat" cmpd="sng" algn="ctr">
-                      <a:solidFill>
-                        <a:srgbClr val="000000"/>
-                      </a:solidFill>
-                      <a:prstDash val="solid"/>
-                      <a:round/>
-                      <a:headEnd type="none" w="med" len="med"/>
-                      <a:tailEnd type="none" w="med" len="med"/>
-                    </a:lnL>
-                    <a:lnR w="12700" cap="flat" cmpd="sng" algn="ctr">
-                      <a:solidFill>
-                        <a:srgbClr val="000000"/>
-                      </a:solidFill>
-                      <a:prstDash val="solid"/>
-                      <a:round/>
-                      <a:headEnd type="none" w="med" len="med"/>
-                      <a:tailEnd type="none" w="med" len="med"/>
-                    </a:lnR>
-                    <a:lnT w="12700" cap="flat" cmpd="sng" algn="ctr">
-                      <a:solidFill>
-                        <a:srgbClr val="000000"/>
-                      </a:solidFill>
-                      <a:prstDash val="solid"/>
-                      <a:round/>
-                      <a:headEnd type="none" w="med" len="med"/>
-                      <a:tailEnd type="none" w="med" len="med"/>
-                    </a:lnT>
-                    <a:lnB w="12700" cap="flat" cmpd="sng" algn="ctr">
-                      <a:solidFill>
-                        <a:srgbClr val="000000"/>
-                      </a:solidFill>
-                      <a:prstDash val="solid"/>
-                      <a:round/>
-                      <a:headEnd type="none" w="med" len="med"/>
-                      <a:tailEnd type="none" w="med" len="med"/>
-                    </a:lnB>
                     <a:solidFill>
-                      <a:srgbClr val="D9F2D0"/>
+                      <a:schemeClr val="bg1"/>
                     </a:solidFill>
                   </a:tcPr>
                 </a:tc>
@@ -6822,16 +6332,13 @@
                       <a:pPr algn="ctr" rtl="0" fontAlgn="b">
                         <a:buNone/>
                       </a:pPr>
-                      <a:r>
-                        <a:rPr lang="en-US" sz="2000" b="0" i="0" u="none" strike="noStrike">
-                          <a:solidFill>
-                            <a:srgbClr val="000000"/>
-                          </a:solidFill>
-                          <a:effectLst/>
-                          <a:latin typeface="Aptos Narrow" panose="020B0004020202020204" pitchFamily="34" charset="0"/>
-                        </a:rPr>
-                        <a:t>69</a:t>
-                      </a:r>
+                      <a:endParaRPr lang="en-US" sz="2000" b="0" i="0" u="none" strike="noStrike">
+                        <a:solidFill>
+                          <a:srgbClr val="000000"/>
+                        </a:solidFill>
+                        <a:effectLst/>
+                        <a:latin typeface="Aptos Narrow" panose="020B0004020202020204" pitchFamily="34" charset="0"/>
+                      </a:endParaRPr>
                     </a:p>
                   </a:txBody>
                   <a:tcPr marL="6350" marR="6350" marT="6350" marB="0" anchor="ctr">
@@ -6872,9 +6379,7 @@
                       <a:tailEnd type="none" w="med" len="med"/>
                     </a:lnB>
                     <a:solidFill>
-                      <a:schemeClr val="bg2">
-                        <a:lumMod val="90000"/>
-                      </a:schemeClr>
+                      <a:schemeClr val="bg1"/>
                     </a:solidFill>
                   </a:tcPr>
                 </a:tc>
@@ -6886,16 +6391,13 @@
                       <a:pPr algn="ctr" rtl="0" fontAlgn="b">
                         <a:buNone/>
                       </a:pPr>
-                      <a:r>
-                        <a:rPr lang="en-US" sz="2000" b="0" i="0" u="none" strike="noStrike">
-                          <a:solidFill>
-                            <a:srgbClr val="000000"/>
-                          </a:solidFill>
-                          <a:effectLst/>
-                          <a:latin typeface="Aptos Narrow" panose="020B0004020202020204" pitchFamily="34" charset="0"/>
-                        </a:rPr>
-                        <a:t>78</a:t>
-                      </a:r>
+                      <a:endParaRPr lang="en-US" sz="2000" b="0" i="0" u="none" strike="noStrike" dirty="0">
+                        <a:solidFill>
+                          <a:srgbClr val="000000"/>
+                        </a:solidFill>
+                        <a:effectLst/>
+                        <a:latin typeface="Aptos Narrow" panose="020B0004020202020204" pitchFamily="34" charset="0"/>
+                      </a:endParaRPr>
                     </a:p>
                   </a:txBody>
                   <a:tcPr marL="6350" marR="6350" marT="6350" marB="0" anchor="ctr">
@@ -6935,7 +6437,9 @@
                       <a:headEnd type="none" w="med" len="med"/>
                       <a:tailEnd type="none" w="med" len="med"/>
                     </a:lnB>
-                    <a:noFill/>
+                    <a:solidFill>
+                      <a:schemeClr val="bg1"/>
+                    </a:solidFill>
                   </a:tcPr>
                 </a:tc>
                 <a:tc>
@@ -6946,16 +6450,13 @@
                       <a:pPr algn="ctr" rtl="0" fontAlgn="b">
                         <a:buNone/>
                       </a:pPr>
-                      <a:r>
-                        <a:rPr lang="en-US" sz="2000" b="0" i="0" u="none" strike="noStrike">
-                          <a:solidFill>
-                            <a:srgbClr val="000000"/>
-                          </a:solidFill>
-                          <a:effectLst/>
-                          <a:latin typeface="Aptos Narrow" panose="020B0004020202020204" pitchFamily="34" charset="0"/>
-                        </a:rPr>
-                        <a:t>67</a:t>
-                      </a:r>
+                      <a:endParaRPr lang="en-US" sz="2000" b="0" i="0" u="none" strike="noStrike" dirty="0">
+                        <a:solidFill>
+                          <a:srgbClr val="000000"/>
+                        </a:solidFill>
+                        <a:effectLst/>
+                        <a:latin typeface="Aptos Narrow" panose="020B0004020202020204" pitchFamily="34" charset="0"/>
+                      </a:endParaRPr>
                     </a:p>
                   </a:txBody>
                   <a:tcPr marL="6350" marR="6350" marT="6350" marB="0" anchor="ctr">
@@ -6995,7 +6496,9 @@
                       <a:headEnd type="none" w="med" len="med"/>
                       <a:tailEnd type="none" w="med" len="med"/>
                     </a:lnB>
-                    <a:noFill/>
+                    <a:solidFill>
+                      <a:schemeClr val="bg1"/>
+                    </a:solidFill>
                   </a:tcPr>
                 </a:tc>
                 <a:tc>
@@ -7006,16 +6509,13 @@
                       <a:pPr algn="ctr" rtl="0" fontAlgn="b">
                         <a:buNone/>
                       </a:pPr>
-                      <a:r>
-                        <a:rPr lang="en-US" sz="2000" b="0" i="0" u="none" strike="noStrike">
-                          <a:solidFill>
-                            <a:srgbClr val="000000"/>
-                          </a:solidFill>
-                          <a:effectLst/>
-                          <a:latin typeface="Aptos Narrow" panose="020B0004020202020204" pitchFamily="34" charset="0"/>
-                        </a:rPr>
-                        <a:t>66</a:t>
-                      </a:r>
+                      <a:endParaRPr lang="en-US" sz="2000" b="0" i="0" u="none" strike="noStrike" dirty="0">
+                        <a:solidFill>
+                          <a:srgbClr val="000000"/>
+                        </a:solidFill>
+                        <a:effectLst/>
+                        <a:latin typeface="Aptos Narrow" panose="020B0004020202020204" pitchFamily="34" charset="0"/>
+                      </a:endParaRPr>
                     </a:p>
                   </a:txBody>
                   <a:tcPr marL="6350" marR="6350" marT="6350" marB="0" anchor="ctr">
@@ -7055,7 +6555,68 @@
                       <a:headEnd type="none" w="med" len="med"/>
                       <a:tailEnd type="none" w="med" len="med"/>
                     </a:lnB>
-                    <a:noFill/>
+                    <a:solidFill>
+                      <a:schemeClr val="bg1"/>
+                    </a:solidFill>
+                  </a:tcPr>
+                </a:tc>
+                <a:tc>
+                  <a:txBody>
+                    <a:bodyPr/>
+                    <a:lstStyle/>
+                    <a:p>
+                      <a:pPr algn="ctr" rtl="0" fontAlgn="b">
+                        <a:buNone/>
+                      </a:pPr>
+                      <a:endParaRPr lang="en-US" sz="2000" b="0" i="0" u="none" strike="noStrike" dirty="0">
+                        <a:solidFill>
+                          <a:srgbClr val="000000"/>
+                        </a:solidFill>
+                        <a:effectLst/>
+                        <a:latin typeface="Aptos Narrow" panose="020B0004020202020204" pitchFamily="34" charset="0"/>
+                      </a:endParaRPr>
+                    </a:p>
+                  </a:txBody>
+                  <a:tcPr marL="6350" marR="6350" marT="6350" marB="0" anchor="ctr">
+                    <a:lnL w="12700" cap="flat" cmpd="sng" algn="ctr">
+                      <a:solidFill>
+                        <a:srgbClr val="000000"/>
+                      </a:solidFill>
+                      <a:prstDash val="solid"/>
+                      <a:round/>
+                      <a:headEnd type="none" w="med" len="med"/>
+                      <a:tailEnd type="none" w="med" len="med"/>
+                    </a:lnL>
+                    <a:lnR w="12700" cap="flat" cmpd="sng" algn="ctr">
+                      <a:solidFill>
+                        <a:srgbClr val="000000"/>
+                      </a:solidFill>
+                      <a:prstDash val="solid"/>
+                      <a:round/>
+                      <a:headEnd type="none" w="med" len="med"/>
+                      <a:tailEnd type="none" w="med" len="med"/>
+                    </a:lnR>
+                    <a:lnT w="12700" cap="flat" cmpd="sng" algn="ctr">
+                      <a:solidFill>
+                        <a:srgbClr val="000000"/>
+                      </a:solidFill>
+                      <a:prstDash val="solid"/>
+                      <a:round/>
+                      <a:headEnd type="none" w="med" len="med"/>
+                      <a:tailEnd type="none" w="med" len="med"/>
+                    </a:lnT>
+                    <a:lnB w="12700" cap="flat" cmpd="sng" algn="ctr">
+                      <a:solidFill>
+                        <a:srgbClr val="000000"/>
+                      </a:solidFill>
+                      <a:prstDash val="solid"/>
+                      <a:round/>
+                      <a:headEnd type="none" w="med" len="med"/>
+                      <a:tailEnd type="none" w="med" len="med"/>
+                    </a:lnB>
+                    <a:solidFill>
+                      <a:schemeClr val="bg1"/>
+                    </a:solidFill>
                   </a:tcPr>
                 </a:tc>
                 <a:extLst>
@@ -7064,7 +6625,7 @@
                   </a:ext>
                 </a:extLst>
               </a:tr>
-              <a:tr h="1250215">
+              <a:tr h="1024255">
                 <a:tc>
                   <a:txBody>
                     <a:bodyPr/>
@@ -7074,7 +6635,7 @@
                         <a:buNone/>
                       </a:pPr>
                       <a:r>
-                        <a:rPr lang="en-US" sz="2800" b="0" i="0" u="none" strike="noStrike">
+                        <a:rPr lang="en-US" sz="2800" b="0" i="0" u="none" strike="noStrike" dirty="0">
                           <a:solidFill>
                             <a:srgbClr val="000000"/>
                           </a:solidFill>
@@ -7148,31 +6709,21 @@
                         <a:defRPr/>
                       </a:pPr>
                       <a:r>
-                        <a:rPr lang="en-US" sz="2800" b="0" i="0" u="none" strike="noStrike">
-                          <a:solidFill>
-                            <a:srgbClr val="000000"/>
-                          </a:solidFill>
-                          <a:effectLst/>
-                          <a:latin typeface="Arial" panose="020B0604020202020204" pitchFamily="34" charset="0"/>
-                        </a:rPr>
-                        <a:t> </a:t>
-                      </a:r>
-                      <a:r>
-                        <a:rPr lang="en-US" sz="1600" b="1" i="0" u="none" strike="noStrike">
+                        <a:rPr lang="en-US" sz="1600" b="1" i="0" u="none" strike="noStrike" dirty="0">
                           <a:solidFill>
                             <a:srgbClr val="000000"/>
                           </a:solidFill>
                           <a:effectLst/>
                           <a:latin typeface="Aptos Narrow" panose="020B0004020202020204" pitchFamily="34" charset="0"/>
                         </a:rPr>
-                        <a:t>Monomer% loss D0-D3</a:t>
+                        <a:t>%Monomer loss D0-D3</a:t>
                       </a:r>
                     </a:p>
                     <a:p>
                       <a:pPr algn="ctr" fontAlgn="ctr">
                         <a:buNone/>
                       </a:pPr>
-                      <a:endParaRPr lang="en-US" sz="2800" b="0" i="0" u="none" strike="noStrike">
+                      <a:endParaRPr lang="en-US" sz="2800" b="0" i="0" u="none" strike="noStrike" dirty="0">
                         <a:solidFill>
                           <a:srgbClr val="000000"/>
                         </a:solidFill>
@@ -7229,7 +6780,7 @@
                       <a:pPr algn="ctr" rtl="0" fontAlgn="b">
                         <a:buNone/>
                       </a:pPr>
-                      <a:endParaRPr lang="en-US" sz="1600" b="1" i="0" u="none" strike="noStrike">
+                      <a:endParaRPr lang="en-US" sz="1600" b="1" i="0" u="none" strike="noStrike" dirty="0">
                         <a:solidFill>
                           <a:srgbClr val="000000"/>
                         </a:solidFill>
@@ -7286,16 +6837,13 @@
                       <a:pPr algn="ctr" rtl="0" fontAlgn="b">
                         <a:buNone/>
                       </a:pPr>
-                      <a:r>
-                        <a:rPr lang="en-US" sz="2000" b="0" i="0" u="none" strike="noStrike">
-                          <a:solidFill>
-                            <a:srgbClr val="000000"/>
-                          </a:solidFill>
-                          <a:effectLst/>
-                          <a:latin typeface="Aptos Narrow" panose="020B0004020202020204" pitchFamily="34" charset="0"/>
-                        </a:rPr>
-                        <a:t>-4.1</a:t>
-                      </a:r>
+                      <a:endParaRPr lang="en-US" sz="2000" b="0" i="0" u="none" strike="noStrike" dirty="0">
+                        <a:solidFill>
+                          <a:srgbClr val="000000"/>
+                        </a:solidFill>
+                        <a:effectLst/>
+                        <a:latin typeface="Aptos Narrow" panose="020B0004020202020204" pitchFamily="34" charset="0"/>
+                      </a:endParaRPr>
                     </a:p>
                   </a:txBody>
                   <a:tcPr marL="6350" marR="6350" marT="6350" marB="0" anchor="ctr">
@@ -7335,128 +6883,8 @@
                       <a:headEnd type="none" w="med" len="med"/>
                       <a:tailEnd type="none" w="med" len="med"/>
                     </a:lnB>
-                    <a:noFill/>
-                  </a:tcPr>
-                </a:tc>
-                <a:tc>
-                  <a:txBody>
-                    <a:bodyPr/>
-                    <a:lstStyle/>
-                    <a:p>
-                      <a:pPr algn="ctr" rtl="0" fontAlgn="b">
-                        <a:buNone/>
-                      </a:pPr>
-                      <a:r>
-                        <a:rPr lang="en-US" sz="2000" b="0" i="0" u="none" strike="noStrike">
-                          <a:solidFill>
-                            <a:srgbClr val="000000"/>
-                          </a:solidFill>
-                          <a:effectLst/>
-                          <a:latin typeface="Aptos Narrow" panose="020B0004020202020204" pitchFamily="34" charset="0"/>
-                        </a:rPr>
-                        <a:t>-4.9</a:t>
-                      </a:r>
-                    </a:p>
-                  </a:txBody>
-                  <a:tcPr marL="6350" marR="6350" marT="6350" marB="0" anchor="ctr">
-                    <a:lnL w="12700" cap="flat" cmpd="sng" algn="ctr">
-                      <a:solidFill>
-                        <a:srgbClr val="000000"/>
-                      </a:solidFill>
-                      <a:prstDash val="solid"/>
-                      <a:round/>
-                      <a:headEnd type="none" w="med" len="med"/>
-                      <a:tailEnd type="none" w="med" len="med"/>
-                    </a:lnL>
-                    <a:lnR w="12700" cap="flat" cmpd="sng" algn="ctr">
-                      <a:solidFill>
-                        <a:srgbClr val="000000"/>
-                      </a:solidFill>
-                      <a:prstDash val="solid"/>
-                      <a:round/>
-                      <a:headEnd type="none" w="med" len="med"/>
-                      <a:tailEnd type="none" w="med" len="med"/>
-                    </a:lnR>
-                    <a:lnT w="12700" cap="flat" cmpd="sng" algn="ctr">
-                      <a:solidFill>
-                        <a:srgbClr val="000000"/>
-                      </a:solidFill>
-                      <a:prstDash val="solid"/>
-                      <a:round/>
-                      <a:headEnd type="none" w="med" len="med"/>
-                      <a:tailEnd type="none" w="med" len="med"/>
-                    </a:lnT>
-                    <a:lnB w="12700" cap="flat" cmpd="sng" algn="ctr">
-                      <a:solidFill>
-                        <a:srgbClr val="000000"/>
-                      </a:solidFill>
-                      <a:prstDash val="solid"/>
-                      <a:round/>
-                      <a:headEnd type="none" w="med" len="med"/>
-                      <a:tailEnd type="none" w="med" len="med"/>
-                    </a:lnB>
-                    <a:noFill/>
-                  </a:tcPr>
-                </a:tc>
-                <a:tc>
-                  <a:txBody>
-                    <a:bodyPr/>
-                    <a:lstStyle/>
-                    <a:p>
-                      <a:pPr algn="ctr" rtl="0" fontAlgn="b">
-                        <a:buNone/>
-                      </a:pPr>
-                      <a:r>
-                        <a:rPr lang="en-US" sz="2000" b="0" i="0" u="none" strike="noStrike">
-                          <a:solidFill>
-                            <a:srgbClr val="000000"/>
-                          </a:solidFill>
-                          <a:effectLst/>
-                          <a:latin typeface="Aptos Narrow" panose="020B0004020202020204" pitchFamily="34" charset="0"/>
-                        </a:rPr>
-                        <a:t>5.9</a:t>
-                      </a:r>
-                    </a:p>
-                  </a:txBody>
-                  <a:tcPr marL="6350" marR="6350" marT="6350" marB="0" anchor="ctr">
-                    <a:lnL w="12700" cap="flat" cmpd="sng" algn="ctr">
-                      <a:solidFill>
-                        <a:srgbClr val="000000"/>
-                      </a:solidFill>
-                      <a:prstDash val="solid"/>
-                      <a:round/>
-                      <a:headEnd type="none" w="med" len="med"/>
-                      <a:tailEnd type="none" w="med" len="med"/>
-                    </a:lnL>
-                    <a:lnR w="12700" cap="flat" cmpd="sng" algn="ctr">
-                      <a:solidFill>
-                        <a:srgbClr val="000000"/>
-                      </a:solidFill>
-                      <a:prstDash val="solid"/>
-                      <a:round/>
-                      <a:headEnd type="none" w="med" len="med"/>
-                      <a:tailEnd type="none" w="med" len="med"/>
-                    </a:lnR>
-                    <a:lnT w="12700" cap="flat" cmpd="sng" algn="ctr">
-                      <a:solidFill>
-                        <a:srgbClr val="000000"/>
-                      </a:solidFill>
-                      <a:prstDash val="solid"/>
-                      <a:round/>
-                      <a:headEnd type="none" w="med" len="med"/>
-                      <a:tailEnd type="none" w="med" len="med"/>
-                    </a:lnT>
-                    <a:lnB w="12700" cap="flat" cmpd="sng" algn="ctr">
-                      <a:solidFill>
-                        <a:srgbClr val="000000"/>
-                      </a:solidFill>
-                      <a:prstDash val="solid"/>
-                      <a:round/>
-                      <a:headEnd type="none" w="med" len="med"/>
-                      <a:tailEnd type="none" w="med" len="med"/>
-                    </a:lnB>
                     <a:solidFill>
-                      <a:srgbClr val="D9F2D0"/>
+                      <a:schemeClr val="bg1"/>
                     </a:solidFill>
                   </a:tcPr>
                 </a:tc>
@@ -7468,16 +6896,13 @@
                       <a:pPr algn="ctr" rtl="0" fontAlgn="b">
                         <a:buNone/>
                       </a:pPr>
-                      <a:r>
-                        <a:rPr lang="en-US" sz="2000" b="0" i="0" u="none" strike="noStrike">
-                          <a:solidFill>
-                            <a:srgbClr val="000000"/>
-                          </a:solidFill>
-                          <a:effectLst/>
-                          <a:latin typeface="Aptos Narrow" panose="020B0004020202020204" pitchFamily="34" charset="0"/>
-                        </a:rPr>
-                        <a:t>-2.7</a:t>
-                      </a:r>
+                      <a:endParaRPr lang="en-US" sz="2000" b="0" i="0" u="none" strike="noStrike" dirty="0">
+                        <a:solidFill>
+                          <a:srgbClr val="000000"/>
+                        </a:solidFill>
+                        <a:effectLst/>
+                        <a:latin typeface="Aptos Narrow" panose="020B0004020202020204" pitchFamily="34" charset="0"/>
+                      </a:endParaRPr>
                     </a:p>
                   </a:txBody>
                   <a:tcPr marL="6350" marR="6350" marT="6350" marB="0" anchor="ctr">
@@ -7517,7 +6942,9 @@
                       <a:headEnd type="none" w="med" len="med"/>
                       <a:tailEnd type="none" w="med" len="med"/>
                     </a:lnB>
-                    <a:noFill/>
+                    <a:solidFill>
+                      <a:schemeClr val="bg1"/>
+                    </a:solidFill>
                   </a:tcPr>
                 </a:tc>
                 <a:tc>
@@ -7528,16 +6955,13 @@
                       <a:pPr algn="ctr" rtl="0" fontAlgn="b">
                         <a:buNone/>
                       </a:pPr>
-                      <a:r>
-                        <a:rPr lang="en-US" sz="2000" b="0" i="0" u="none" strike="noStrike">
-                          <a:solidFill>
-                            <a:srgbClr val="000000"/>
-                          </a:solidFill>
-                          <a:effectLst/>
-                          <a:latin typeface="Aptos Narrow" panose="020B0004020202020204" pitchFamily="34" charset="0"/>
-                        </a:rPr>
-                        <a:t>-2.2</a:t>
-                      </a:r>
+                      <a:endParaRPr lang="en-US" sz="2000" b="0" i="0" u="none" strike="noStrike" dirty="0">
+                        <a:solidFill>
+                          <a:srgbClr val="000000"/>
+                        </a:solidFill>
+                        <a:effectLst/>
+                        <a:latin typeface="Aptos Narrow" panose="020B0004020202020204" pitchFamily="34" charset="0"/>
+                      </a:endParaRPr>
                     </a:p>
                   </a:txBody>
                   <a:tcPr marL="6350" marR="6350" marT="6350" marB="0" anchor="ctr">
@@ -7577,7 +7001,9 @@
                       <a:headEnd type="none" w="med" len="med"/>
                       <a:tailEnd type="none" w="med" len="med"/>
                     </a:lnB>
-                    <a:noFill/>
+                    <a:solidFill>
+                      <a:schemeClr val="bg1"/>
+                    </a:solidFill>
                   </a:tcPr>
                 </a:tc>
                 <a:tc>
@@ -7588,16 +7014,13 @@
                       <a:pPr algn="ctr" rtl="0" fontAlgn="b">
                         <a:buNone/>
                       </a:pPr>
-                      <a:r>
-                        <a:rPr lang="en-US" sz="2000" b="0" i="0" u="none" strike="noStrike">
-                          <a:solidFill>
-                            <a:srgbClr val="000000"/>
-                          </a:solidFill>
-                          <a:effectLst/>
-                          <a:latin typeface="Aptos Narrow" panose="020B0004020202020204" pitchFamily="34" charset="0"/>
-                        </a:rPr>
-                        <a:t>-1.4</a:t>
-                      </a:r>
+                      <a:endParaRPr lang="en-US" sz="2000" b="0" i="0" u="none" strike="noStrike" dirty="0">
+                        <a:solidFill>
+                          <a:srgbClr val="000000"/>
+                        </a:solidFill>
+                        <a:effectLst/>
+                        <a:latin typeface="Aptos Narrow" panose="020B0004020202020204" pitchFamily="34" charset="0"/>
+                      </a:endParaRPr>
                     </a:p>
                   </a:txBody>
                   <a:tcPr marL="6350" marR="6350" marT="6350" marB="0" anchor="ctr">
@@ -7637,7 +7060,9 @@
                       <a:headEnd type="none" w="med" len="med"/>
                       <a:tailEnd type="none" w="med" len="med"/>
                     </a:lnB>
-                    <a:noFill/>
+                    <a:solidFill>
+                      <a:schemeClr val="bg1"/>
+                    </a:solidFill>
                   </a:tcPr>
                 </a:tc>
                 <a:tc>
@@ -7648,16 +7073,13 @@
                       <a:pPr algn="ctr" rtl="0" fontAlgn="b">
                         <a:buNone/>
                       </a:pPr>
-                      <a:r>
-                        <a:rPr lang="en-US" sz="2000" b="0" i="0" u="none" strike="noStrike">
-                          <a:solidFill>
-                            <a:srgbClr val="000000"/>
-                          </a:solidFill>
-                          <a:effectLst/>
-                          <a:latin typeface="Aptos Narrow" panose="020B0004020202020204" pitchFamily="34" charset="0"/>
-                        </a:rPr>
-                        <a:t>-5.7</a:t>
-                      </a:r>
+                      <a:endParaRPr lang="en-US" sz="2000" b="0" i="0" u="none" strike="noStrike" dirty="0">
+                        <a:solidFill>
+                          <a:srgbClr val="000000"/>
+                        </a:solidFill>
+                        <a:effectLst/>
+                        <a:latin typeface="Aptos Narrow" panose="020B0004020202020204" pitchFamily="34" charset="0"/>
+                      </a:endParaRPr>
                     </a:p>
                   </a:txBody>
                   <a:tcPr marL="6350" marR="6350" marT="6350" marB="0" anchor="ctr">
@@ -7697,7 +7119,68 @@
                       <a:headEnd type="none" w="med" len="med"/>
                       <a:tailEnd type="none" w="med" len="med"/>
                     </a:lnB>
-                    <a:noFill/>
+                    <a:solidFill>
+                      <a:schemeClr val="bg1"/>
+                    </a:solidFill>
+                  </a:tcPr>
+                </a:tc>
+                <a:tc>
+                  <a:txBody>
+                    <a:bodyPr/>
+                    <a:lstStyle/>
+                    <a:p>
+                      <a:pPr algn="ctr" rtl="0" fontAlgn="b">
+                        <a:buNone/>
+                      </a:pPr>
+                      <a:endParaRPr lang="en-US" sz="2000" b="0" i="0" u="none" strike="noStrike" dirty="0">
+                        <a:solidFill>
+                          <a:srgbClr val="000000"/>
+                        </a:solidFill>
+                        <a:effectLst/>
+                        <a:latin typeface="Aptos Narrow" panose="020B0004020202020204" pitchFamily="34" charset="0"/>
+                      </a:endParaRPr>
+                    </a:p>
+                  </a:txBody>
+                  <a:tcPr marL="6350" marR="6350" marT="6350" marB="0" anchor="ctr">
+                    <a:lnL w="12700" cap="flat" cmpd="sng" algn="ctr">
+                      <a:solidFill>
+                        <a:srgbClr val="000000"/>
+                      </a:solidFill>
+                      <a:prstDash val="solid"/>
+                      <a:round/>
+                      <a:headEnd type="none" w="med" len="med"/>
+                      <a:tailEnd type="none" w="med" len="med"/>
+                    </a:lnL>
+                    <a:lnR w="12700" cap="flat" cmpd="sng" algn="ctr">
+                      <a:solidFill>
+                        <a:srgbClr val="000000"/>
+                      </a:solidFill>
+                      <a:prstDash val="solid"/>
+                      <a:round/>
+                      <a:headEnd type="none" w="med" len="med"/>
+                      <a:tailEnd type="none" w="med" len="med"/>
+                    </a:lnR>
+                    <a:lnT w="12700" cap="flat" cmpd="sng" algn="ctr">
+                      <a:solidFill>
+                        <a:srgbClr val="000000"/>
+                      </a:solidFill>
+                      <a:prstDash val="solid"/>
+                      <a:round/>
+                      <a:headEnd type="none" w="med" len="med"/>
+                      <a:tailEnd type="none" w="med" len="med"/>
+                    </a:lnT>
+                    <a:lnB w="12700" cap="flat" cmpd="sng" algn="ctr">
+                      <a:solidFill>
+                        <a:srgbClr val="000000"/>
+                      </a:solidFill>
+                      <a:prstDash val="solid"/>
+                      <a:round/>
+                      <a:headEnd type="none" w="med" len="med"/>
+                      <a:tailEnd type="none" w="med" len="med"/>
+                    </a:lnB>
+                    <a:solidFill>
+                      <a:schemeClr val="bg1"/>
+                    </a:solidFill>
                   </a:tcPr>
                 </a:tc>
                 <a:extLst>
@@ -7710,261 +7193,6 @@
           </a:graphicData>
         </a:graphic>
       </p:graphicFrame>
-      <p:pic>
-        <p:nvPicPr>
-          <p:cNvPr id="3" name="Picture 2">
-            <a:extLst>
-              <a:ext uri="{FF2B5EF4-FFF2-40B4-BE49-F238E27FC236}">
-                <a16:creationId xmlns:a16="http://schemas.microsoft.com/office/drawing/2014/main" id="{71143ED1-BADC-0E78-3C51-5BCB4E380C47}"/>
-              </a:ext>
-            </a:extLst>
-          </p:cNvPr>
-          <p:cNvPicPr>
-            <a:picLocks noChangeAspect="1"/>
-          </p:cNvPicPr>
-          <p:nvPr/>
-        </p:nvPicPr>
-        <p:blipFill>
-          <a:blip r:embed="rId3"/>
-          <a:stretch>
-            <a:fillRect/>
-          </a:stretch>
-        </p:blipFill>
-        <p:spPr>
-          <a:xfrm>
-            <a:off x="10727444" y="263719"/>
-            <a:ext cx="1165772" cy="1266850"/>
-          </a:xfrm>
-          <a:prstGeom prst="rect">
-            <a:avLst/>
-          </a:prstGeom>
-        </p:spPr>
-      </p:pic>
-      <p:pic>
-        <p:nvPicPr>
-          <p:cNvPr id="6" name="Picture 5">
-            <a:extLst>
-              <a:ext uri="{FF2B5EF4-FFF2-40B4-BE49-F238E27FC236}">
-                <a16:creationId xmlns:a16="http://schemas.microsoft.com/office/drawing/2014/main" id="{8CDED543-CCC2-56B5-5E7C-DD295F24AF21}"/>
-              </a:ext>
-            </a:extLst>
-          </p:cNvPr>
-          <p:cNvPicPr>
-            <a:picLocks noChangeAspect="1"/>
-          </p:cNvPicPr>
-          <p:nvPr/>
-        </p:nvPicPr>
-        <p:blipFill>
-          <a:blip r:embed="rId4"/>
-          <a:stretch>
-            <a:fillRect/>
-          </a:stretch>
-        </p:blipFill>
-        <p:spPr>
-          <a:xfrm>
-            <a:off x="6096000" y="375073"/>
-            <a:ext cx="1401622" cy="1091649"/>
-          </a:xfrm>
-          <a:prstGeom prst="rect">
-            <a:avLst/>
-          </a:prstGeom>
-        </p:spPr>
-      </p:pic>
-      <p:pic>
-        <p:nvPicPr>
-          <p:cNvPr id="7" name="Picture 6">
-            <a:extLst>
-              <a:ext uri="{FF2B5EF4-FFF2-40B4-BE49-F238E27FC236}">
-                <a16:creationId xmlns:a16="http://schemas.microsoft.com/office/drawing/2014/main" id="{0C2CC16E-32F2-E9FF-D982-B042B59EED97}"/>
-              </a:ext>
-            </a:extLst>
-          </p:cNvPr>
-          <p:cNvPicPr>
-            <a:picLocks noChangeAspect="1"/>
-          </p:cNvPicPr>
-          <p:nvPr/>
-        </p:nvPicPr>
-        <p:blipFill>
-          <a:blip r:embed="rId5"/>
-          <a:stretch>
-            <a:fillRect/>
-          </a:stretch>
-        </p:blipFill>
-        <p:spPr>
-          <a:xfrm>
-            <a:off x="9596012" y="310246"/>
-            <a:ext cx="1165772" cy="1280328"/>
-          </a:xfrm>
-          <a:prstGeom prst="rect">
-            <a:avLst/>
-          </a:prstGeom>
-        </p:spPr>
-      </p:pic>
-      <p:pic>
-        <p:nvPicPr>
-          <p:cNvPr id="8" name="Picture 7">
-            <a:extLst>
-              <a:ext uri="{FF2B5EF4-FFF2-40B4-BE49-F238E27FC236}">
-                <a16:creationId xmlns:a16="http://schemas.microsoft.com/office/drawing/2014/main" id="{67404BD2-DC07-648D-7F62-361B9B7F371B}"/>
-              </a:ext>
-            </a:extLst>
-          </p:cNvPr>
-          <p:cNvPicPr>
-            <a:picLocks noChangeAspect="1"/>
-          </p:cNvPicPr>
-          <p:nvPr/>
-        </p:nvPicPr>
-        <p:blipFill>
-          <a:blip r:embed="rId6"/>
-          <a:stretch>
-            <a:fillRect/>
-          </a:stretch>
-        </p:blipFill>
-        <p:spPr>
-          <a:xfrm>
-            <a:off x="4990370" y="310246"/>
-            <a:ext cx="1078171" cy="1340975"/>
-          </a:xfrm>
-          <a:prstGeom prst="rect">
-            <a:avLst/>
-          </a:prstGeom>
-        </p:spPr>
-      </p:pic>
-      <p:pic>
-        <p:nvPicPr>
-          <p:cNvPr id="10" name="Picture 9">
-            <a:extLst>
-              <a:ext uri="{FF2B5EF4-FFF2-40B4-BE49-F238E27FC236}">
-                <a16:creationId xmlns:a16="http://schemas.microsoft.com/office/drawing/2014/main" id="{BD714FE3-46E0-5DF3-9643-4D5805FC7EB1}"/>
-              </a:ext>
-            </a:extLst>
-          </p:cNvPr>
-          <p:cNvPicPr>
-            <a:picLocks noChangeAspect="1"/>
-          </p:cNvPicPr>
-          <p:nvPr/>
-        </p:nvPicPr>
-        <p:blipFill>
-          <a:blip r:embed="rId7"/>
-          <a:stretch>
-            <a:fillRect/>
-          </a:stretch>
-        </p:blipFill>
-        <p:spPr>
-          <a:xfrm>
-            <a:off x="8402781" y="290733"/>
-            <a:ext cx="1165772" cy="1266850"/>
-          </a:xfrm>
-          <a:prstGeom prst="rect">
-            <a:avLst/>
-          </a:prstGeom>
-        </p:spPr>
-      </p:pic>
-      <p:pic>
-        <p:nvPicPr>
-          <p:cNvPr id="12" name="Picture 11">
-            <a:extLst>
-              <a:ext uri="{FF2B5EF4-FFF2-40B4-BE49-F238E27FC236}">
-                <a16:creationId xmlns:a16="http://schemas.microsoft.com/office/drawing/2014/main" id="{80643B85-7CDB-CF8D-25CE-7F1BDDBAFB29}"/>
-              </a:ext>
-            </a:extLst>
-          </p:cNvPr>
-          <p:cNvPicPr>
-            <a:picLocks noChangeAspect="1"/>
-          </p:cNvPicPr>
-          <p:nvPr/>
-        </p:nvPicPr>
-        <p:blipFill>
-          <a:blip r:embed="rId8"/>
-          <a:stretch>
-            <a:fillRect/>
-          </a:stretch>
-        </p:blipFill>
-        <p:spPr>
-          <a:xfrm>
-            <a:off x="3380499" y="263719"/>
-            <a:ext cx="1556610" cy="1300544"/>
-          </a:xfrm>
-          <a:prstGeom prst="rect">
-            <a:avLst/>
-          </a:prstGeom>
-        </p:spPr>
-      </p:pic>
-      <p:pic>
-        <p:nvPicPr>
-          <p:cNvPr id="13" name="Picture 12">
-            <a:extLst>
-              <a:ext uri="{FF2B5EF4-FFF2-40B4-BE49-F238E27FC236}">
-                <a16:creationId xmlns:a16="http://schemas.microsoft.com/office/drawing/2014/main" id="{615703FF-9095-F13A-0000-13F00F724E31}"/>
-              </a:ext>
-            </a:extLst>
-          </p:cNvPr>
-          <p:cNvPicPr>
-            <a:picLocks noChangeAspect="1"/>
-          </p:cNvPicPr>
-          <p:nvPr/>
-        </p:nvPicPr>
-        <p:blipFill>
-          <a:blip r:embed="rId9"/>
-          <a:stretch>
-            <a:fillRect/>
-          </a:stretch>
-        </p:blipFill>
-        <p:spPr>
-          <a:xfrm>
-            <a:off x="7397679" y="387633"/>
-            <a:ext cx="1132080" cy="1280328"/>
-          </a:xfrm>
-          <a:prstGeom prst="rect">
-            <a:avLst/>
-          </a:prstGeom>
-        </p:spPr>
-      </p:pic>
-      <p:sp>
-        <p:nvSpPr>
-          <p:cNvPr id="2" name="TextBox 1">
-            <a:extLst>
-              <a:ext uri="{FF2B5EF4-FFF2-40B4-BE49-F238E27FC236}">
-                <a16:creationId xmlns:a16="http://schemas.microsoft.com/office/drawing/2014/main" id="{0B0A9C26-A295-AAF6-3018-E1B569A4EC0D}"/>
-              </a:ext>
-            </a:extLst>
-          </p:cNvPr>
-          <p:cNvSpPr txBox="1"/>
-          <p:nvPr/>
-        </p:nvSpPr>
-        <p:spPr>
-          <a:xfrm>
-            <a:off x="6979134" y="6195127"/>
-            <a:ext cx="4787752" cy="646331"/>
-          </a:xfrm>
-          <a:prstGeom prst="rect">
-            <a:avLst/>
-          </a:prstGeom>
-          <a:solidFill>
-            <a:schemeClr val="bg2">
-              <a:lumMod val="90000"/>
-            </a:schemeClr>
-          </a:solidFill>
-        </p:spPr>
-        <p:txBody>
-          <a:bodyPr wrap="square" rtlCol="0">
-            <a:spAutoFit/>
-          </a:bodyPr>
-          <a:lstStyle/>
-          <a:p>
-            <a:r>
-              <a:rPr lang="en-US"/>
-              <a:t>Control Identified:</a:t>
-            </a:r>
-          </a:p>
-          <a:p>
-            <a:r>
-              <a:rPr lang="en-US"/>
-              <a:t> Day 0 monomer loss, and stable for 7 days</a:t>
-            </a:r>
-          </a:p>
-        </p:txBody>
-      </p:sp>
     </p:spTree>
     <p:extLst>
       <p:ext uri="{BB962C8B-B14F-4D97-AF65-F5344CB8AC3E}">

</xml_diff>